<commit_message>
Slides and PDF uploaded
</commit_message>
<xml_diff>
--- a/MUC - StudentResearchCompetition/SlidesPresentation/SRC_Presentation_Jupyter_Dashboard.pptx
+++ b/MUC - StudentResearchCompetition/SlidesPresentation/SRC_Presentation_Jupyter_Dashboard.pptx
@@ -69,20 +69,21 @@
             <a:noAutofit/>
           </a:bodyPr>
           <a:p>
-            <a:r>
-              <a:rPr b="0" lang="en-US" sz="1800" spc="-1" strike="noStrike">
-                <a:solidFill>
-                  <a:schemeClr val="dk1"/>
-                </a:solidFill>
-                <a:latin typeface="Calibri"/>
+            <a:pPr algn="ctr"/>
+            <a:r>
+              <a:rPr b="0" lang="en-US" sz="4400" spc="-1" strike="noStrike">
+                <a:solidFill>
+                  <a:srgbClr val="000000"/>
+                </a:solidFill>
+                <a:latin typeface="Arial"/>
               </a:rPr>
               <a:t>Click to move the slide</a:t>
             </a:r>
-            <a:endParaRPr b="0" lang="en-US" sz="1800" spc="-1" strike="noStrike">
-              <a:solidFill>
-                <a:schemeClr val="dk1"/>
-              </a:solidFill>
-              <a:latin typeface="Calibri"/>
+            <a:endParaRPr b="0" lang="en-US" sz="4400" spc="-1" strike="noStrike">
+              <a:solidFill>
+                <a:srgbClr val="000000"/>
+              </a:solidFill>
+              <a:latin typeface="Arial"/>
             </a:endParaRPr>
           </a:p>
         </p:txBody>
@@ -347,7 +348,7 @@
             <a:pPr indent="0" algn="r">
               <a:buNone/>
             </a:pPr>
-            <a:fld id="{100AAC9D-A7B6-41D9-ACD3-7FB44608291C}" type="slidenum">
+            <a:fld id="{99C48CF3-E9DD-42D8-ADCB-51A0C5F3DEEB}" type="slidenum">
               <a:rPr b="0" lang="en-US" sz="1400" spc="-1" strike="noStrike">
                 <a:solidFill>
                   <a:srgbClr val="000000"/>
@@ -390,7 +391,7 @@
       </p:grpSpPr>
       <p:sp>
         <p:nvSpPr>
-          <p:cNvPr id="210" name="PlaceHolder 1"/>
+          <p:cNvPr id="214" name="PlaceHolder 1"/>
           <p:cNvSpPr>
             <a:spLocks noGrp="1"/>
           </p:cNvSpPr>
@@ -401,19 +402,19 @@
         <p:spPr>
           <a:xfrm>
             <a:off x="685800" y="1143000"/>
-            <a:ext cx="5486040" cy="3085920"/>
-          </a:xfrm>
-          <a:prstGeom prst="rect">
-            <a:avLst/>
-          </a:prstGeom>
-          <a:ln w="0">
-            <a:noFill/>
-          </a:ln>
-        </p:spPr>
-      </p:sp>
-      <p:sp>
-        <p:nvSpPr>
-          <p:cNvPr id="211" name="PlaceHolder 2"/>
+            <a:ext cx="5485680" cy="3085560"/>
+          </a:xfrm>
+          <a:prstGeom prst="rect">
+            <a:avLst/>
+          </a:prstGeom>
+          <a:ln w="0">
+            <a:noFill/>
+          </a:ln>
+        </p:spPr>
+      </p:sp>
+      <p:sp>
+        <p:nvSpPr>
+          <p:cNvPr id="215" name="PlaceHolder 2"/>
           <p:cNvSpPr>
             <a:spLocks noGrp="1"/>
           </p:cNvSpPr>
@@ -424,7 +425,7 @@
         <p:spPr>
           <a:xfrm>
             <a:off x="685800" y="4400640"/>
-            <a:ext cx="5486040" cy="3600000"/>
+            <a:ext cx="5485680" cy="3599640"/>
           </a:xfrm>
           <a:prstGeom prst="rect">
             <a:avLst/>
@@ -453,7 +454,7 @@
       </p:sp>
       <p:sp>
         <p:nvSpPr>
-          <p:cNvPr id="212" name="PlaceHolder 3"/>
+          <p:cNvPr id="216" name="PlaceHolder 3"/>
           <p:cNvSpPr>
             <a:spLocks noGrp="1"/>
           </p:cNvSpPr>
@@ -464,7 +465,7 @@
         <p:spPr>
           <a:xfrm>
             <a:off x="3884760" y="8685360"/>
-            <a:ext cx="2971440" cy="458280"/>
+            <a:ext cx="2971080" cy="457920"/>
           </a:xfrm>
           <a:prstGeom prst="rect">
             <a:avLst/>
@@ -484,6 +485,9 @@
                 <a:spcPct val="100000"/>
               </a:lnSpc>
               <a:buNone/>
+              <a:tabLst>
+                <a:tab algn="l" pos="0"/>
+              </a:tabLst>
               <a:defRPr b="0" lang="en-US" sz="1200" spc="-1" strike="noStrike">
                 <a:solidFill>
                   <a:schemeClr val="dk1"/>
@@ -499,8 +503,11 @@
                 <a:spcPct val="100000"/>
               </a:lnSpc>
               <a:buNone/>
-            </a:pPr>
-            <a:fld id="{76EBC82E-4E75-4C4B-A864-7ACC0AB1888C}" type="slidenum">
+              <a:tabLst>
+                <a:tab algn="l" pos="0"/>
+              </a:tabLst>
+            </a:pPr>
+            <a:fld id="{DEDB4A2F-222D-4254-9560-FC84D51AAFEF}" type="slidenum">
               <a:rPr b="0" lang="en-US" sz="1200" spc="-1" strike="noStrike">
                 <a:solidFill>
                   <a:schemeClr val="dk1"/>
@@ -543,7 +550,7 @@
       </p:grpSpPr>
       <p:sp>
         <p:nvSpPr>
-          <p:cNvPr id="237" name="PlaceHolder 1"/>
+          <p:cNvPr id="241" name="PlaceHolder 1"/>
           <p:cNvSpPr>
             <a:spLocks noGrp="1"/>
           </p:cNvSpPr>
@@ -554,19 +561,19 @@
         <p:spPr>
           <a:xfrm>
             <a:off x="685800" y="1143000"/>
-            <a:ext cx="5486040" cy="3085920"/>
-          </a:xfrm>
-          <a:prstGeom prst="rect">
-            <a:avLst/>
-          </a:prstGeom>
-          <a:ln w="0">
-            <a:noFill/>
-          </a:ln>
-        </p:spPr>
-      </p:sp>
-      <p:sp>
-        <p:nvSpPr>
-          <p:cNvPr id="238" name="PlaceHolder 2"/>
+            <a:ext cx="5485680" cy="3085560"/>
+          </a:xfrm>
+          <a:prstGeom prst="rect">
+            <a:avLst/>
+          </a:prstGeom>
+          <a:ln w="0">
+            <a:noFill/>
+          </a:ln>
+        </p:spPr>
+      </p:sp>
+      <p:sp>
+        <p:nvSpPr>
+          <p:cNvPr id="242" name="PlaceHolder 2"/>
           <p:cNvSpPr>
             <a:spLocks noGrp="1"/>
           </p:cNvSpPr>
@@ -577,7 +584,7 @@
         <p:spPr>
           <a:xfrm>
             <a:off x="685800" y="4400640"/>
-            <a:ext cx="5486040" cy="3600000"/>
+            <a:ext cx="5485680" cy="3599640"/>
           </a:xfrm>
           <a:prstGeom prst="rect">
             <a:avLst/>
@@ -606,7 +613,7 @@
       </p:sp>
       <p:sp>
         <p:nvSpPr>
-          <p:cNvPr id="239" name="PlaceHolder 3"/>
+          <p:cNvPr id="243" name="PlaceHolder 3"/>
           <p:cNvSpPr>
             <a:spLocks noGrp="1"/>
           </p:cNvSpPr>
@@ -617,7 +624,7 @@
         <p:spPr>
           <a:xfrm>
             <a:off x="3884760" y="8685360"/>
-            <a:ext cx="2971440" cy="458280"/>
+            <a:ext cx="2971080" cy="457920"/>
           </a:xfrm>
           <a:prstGeom prst="rect">
             <a:avLst/>
@@ -637,6 +644,9 @@
                 <a:spcPct val="100000"/>
               </a:lnSpc>
               <a:buNone/>
+              <a:tabLst>
+                <a:tab algn="l" pos="0"/>
+              </a:tabLst>
               <a:defRPr b="0" lang="en-US" sz="1200" spc="-1" strike="noStrike">
                 <a:solidFill>
                   <a:schemeClr val="dk1"/>
@@ -652,8 +662,11 @@
                 <a:spcPct val="100000"/>
               </a:lnSpc>
               <a:buNone/>
-            </a:pPr>
-            <a:fld id="{C4358BB4-5F8F-4CE2-8E6E-FBD9CBE875A7}" type="slidenum">
+              <a:tabLst>
+                <a:tab algn="l" pos="0"/>
+              </a:tabLst>
+            </a:pPr>
+            <a:fld id="{413688F5-4132-4712-A42A-3ADF047A5CFC}" type="slidenum">
               <a:rPr b="0" lang="en-US" sz="1200" spc="-1" strike="noStrike">
                 <a:solidFill>
                   <a:schemeClr val="dk1"/>
@@ -696,7 +709,7 @@
       </p:grpSpPr>
       <p:sp>
         <p:nvSpPr>
-          <p:cNvPr id="213" name="PlaceHolder 1"/>
+          <p:cNvPr id="217" name="PlaceHolder 1"/>
           <p:cNvSpPr>
             <a:spLocks noGrp="1"/>
           </p:cNvSpPr>
@@ -707,19 +720,19 @@
         <p:spPr>
           <a:xfrm>
             <a:off x="685800" y="1143000"/>
-            <a:ext cx="5486040" cy="3085920"/>
-          </a:xfrm>
-          <a:prstGeom prst="rect">
-            <a:avLst/>
-          </a:prstGeom>
-          <a:ln w="0">
-            <a:noFill/>
-          </a:ln>
-        </p:spPr>
-      </p:sp>
-      <p:sp>
-        <p:nvSpPr>
-          <p:cNvPr id="214" name="PlaceHolder 2"/>
+            <a:ext cx="5485680" cy="3085560"/>
+          </a:xfrm>
+          <a:prstGeom prst="rect">
+            <a:avLst/>
+          </a:prstGeom>
+          <a:ln w="0">
+            <a:noFill/>
+          </a:ln>
+        </p:spPr>
+      </p:sp>
+      <p:sp>
+        <p:nvSpPr>
+          <p:cNvPr id="218" name="PlaceHolder 2"/>
           <p:cNvSpPr>
             <a:spLocks noGrp="1"/>
           </p:cNvSpPr>
@@ -730,7 +743,7 @@
         <p:spPr>
           <a:xfrm>
             <a:off x="685800" y="4400640"/>
-            <a:ext cx="5486040" cy="3600000"/>
+            <a:ext cx="5485680" cy="3599640"/>
           </a:xfrm>
           <a:prstGeom prst="rect">
             <a:avLst/>
@@ -759,7 +772,7 @@
       </p:sp>
       <p:sp>
         <p:nvSpPr>
-          <p:cNvPr id="215" name="PlaceHolder 3"/>
+          <p:cNvPr id="219" name="PlaceHolder 3"/>
           <p:cNvSpPr>
             <a:spLocks noGrp="1"/>
           </p:cNvSpPr>
@@ -770,7 +783,7 @@
         <p:spPr>
           <a:xfrm>
             <a:off x="3884760" y="8685360"/>
-            <a:ext cx="2971440" cy="458280"/>
+            <a:ext cx="2971080" cy="457920"/>
           </a:xfrm>
           <a:prstGeom prst="rect">
             <a:avLst/>
@@ -790,6 +803,9 @@
                 <a:spcPct val="100000"/>
               </a:lnSpc>
               <a:buNone/>
+              <a:tabLst>
+                <a:tab algn="l" pos="0"/>
+              </a:tabLst>
               <a:defRPr b="0" lang="en-US" sz="1200" spc="-1" strike="noStrike">
                 <a:solidFill>
                   <a:schemeClr val="dk1"/>
@@ -805,8 +821,11 @@
                 <a:spcPct val="100000"/>
               </a:lnSpc>
               <a:buNone/>
-            </a:pPr>
-            <a:fld id="{D4323906-DDAD-4E1B-BC76-3C3DEEE84EAA}" type="slidenum">
+              <a:tabLst>
+                <a:tab algn="l" pos="0"/>
+              </a:tabLst>
+            </a:pPr>
+            <a:fld id="{7B4BB509-0567-47C7-B938-15F9424C8B64}" type="slidenum">
               <a:rPr b="0" lang="en-US" sz="1200" spc="-1" strike="noStrike">
                 <a:solidFill>
                   <a:schemeClr val="dk1"/>
@@ -849,7 +868,7 @@
       </p:grpSpPr>
       <p:sp>
         <p:nvSpPr>
-          <p:cNvPr id="216" name="PlaceHolder 1"/>
+          <p:cNvPr id="220" name="PlaceHolder 1"/>
           <p:cNvSpPr>
             <a:spLocks noGrp="1"/>
           </p:cNvSpPr>
@@ -860,19 +879,19 @@
         <p:spPr>
           <a:xfrm>
             <a:off x="685800" y="1143000"/>
-            <a:ext cx="5486040" cy="3085920"/>
-          </a:xfrm>
-          <a:prstGeom prst="rect">
-            <a:avLst/>
-          </a:prstGeom>
-          <a:ln w="0">
-            <a:noFill/>
-          </a:ln>
-        </p:spPr>
-      </p:sp>
-      <p:sp>
-        <p:nvSpPr>
-          <p:cNvPr id="217" name="PlaceHolder 2"/>
+            <a:ext cx="5485680" cy="3085560"/>
+          </a:xfrm>
+          <a:prstGeom prst="rect">
+            <a:avLst/>
+          </a:prstGeom>
+          <a:ln w="0">
+            <a:noFill/>
+          </a:ln>
+        </p:spPr>
+      </p:sp>
+      <p:sp>
+        <p:nvSpPr>
+          <p:cNvPr id="221" name="PlaceHolder 2"/>
           <p:cNvSpPr>
             <a:spLocks noGrp="1"/>
           </p:cNvSpPr>
@@ -883,7 +902,7 @@
         <p:spPr>
           <a:xfrm>
             <a:off x="685800" y="4400640"/>
-            <a:ext cx="5486040" cy="3600000"/>
+            <a:ext cx="5485680" cy="3599640"/>
           </a:xfrm>
           <a:prstGeom prst="rect">
             <a:avLst/>
@@ -912,7 +931,7 @@
       </p:sp>
       <p:sp>
         <p:nvSpPr>
-          <p:cNvPr id="218" name="PlaceHolder 3"/>
+          <p:cNvPr id="222" name="PlaceHolder 3"/>
           <p:cNvSpPr>
             <a:spLocks noGrp="1"/>
           </p:cNvSpPr>
@@ -923,7 +942,7 @@
         <p:spPr>
           <a:xfrm>
             <a:off x="3884760" y="8685360"/>
-            <a:ext cx="2971440" cy="458280"/>
+            <a:ext cx="2971080" cy="457920"/>
           </a:xfrm>
           <a:prstGeom prst="rect">
             <a:avLst/>
@@ -943,6 +962,9 @@
                 <a:spcPct val="100000"/>
               </a:lnSpc>
               <a:buNone/>
+              <a:tabLst>
+                <a:tab algn="l" pos="0"/>
+              </a:tabLst>
               <a:defRPr b="0" lang="en-US" sz="1200" spc="-1" strike="noStrike">
                 <a:solidFill>
                   <a:schemeClr val="dk1"/>
@@ -958,8 +980,11 @@
                 <a:spcPct val="100000"/>
               </a:lnSpc>
               <a:buNone/>
-            </a:pPr>
-            <a:fld id="{5A7CD22D-2E0A-4F20-93F1-4BB061158CD5}" type="slidenum">
+              <a:tabLst>
+                <a:tab algn="l" pos="0"/>
+              </a:tabLst>
+            </a:pPr>
+            <a:fld id="{D99A1141-6177-4E19-9F58-6403C58EB9D1}" type="slidenum">
               <a:rPr b="0" lang="en-US" sz="1200" spc="-1" strike="noStrike">
                 <a:solidFill>
                   <a:schemeClr val="dk1"/>
@@ -1002,7 +1027,7 @@
       </p:grpSpPr>
       <p:sp>
         <p:nvSpPr>
-          <p:cNvPr id="219" name="PlaceHolder 1"/>
+          <p:cNvPr id="223" name="PlaceHolder 1"/>
           <p:cNvSpPr>
             <a:spLocks noGrp="1"/>
           </p:cNvSpPr>
@@ -1013,19 +1038,19 @@
         <p:spPr>
           <a:xfrm>
             <a:off x="685800" y="1143000"/>
-            <a:ext cx="5486040" cy="3085920"/>
-          </a:xfrm>
-          <a:prstGeom prst="rect">
-            <a:avLst/>
-          </a:prstGeom>
-          <a:ln w="0">
-            <a:noFill/>
-          </a:ln>
-        </p:spPr>
-      </p:sp>
-      <p:sp>
-        <p:nvSpPr>
-          <p:cNvPr id="220" name="PlaceHolder 2"/>
+            <a:ext cx="5485680" cy="3085560"/>
+          </a:xfrm>
+          <a:prstGeom prst="rect">
+            <a:avLst/>
+          </a:prstGeom>
+          <a:ln w="0">
+            <a:noFill/>
+          </a:ln>
+        </p:spPr>
+      </p:sp>
+      <p:sp>
+        <p:nvSpPr>
+          <p:cNvPr id="224" name="PlaceHolder 2"/>
           <p:cNvSpPr>
             <a:spLocks noGrp="1"/>
           </p:cNvSpPr>
@@ -1036,7 +1061,7 @@
         <p:spPr>
           <a:xfrm>
             <a:off x="685800" y="4400640"/>
-            <a:ext cx="5486040" cy="3600000"/>
+            <a:ext cx="5485680" cy="3599640"/>
           </a:xfrm>
           <a:prstGeom prst="rect">
             <a:avLst/>
@@ -1065,7 +1090,7 @@
       </p:sp>
       <p:sp>
         <p:nvSpPr>
-          <p:cNvPr id="221" name="PlaceHolder 3"/>
+          <p:cNvPr id="225" name="PlaceHolder 3"/>
           <p:cNvSpPr>
             <a:spLocks noGrp="1"/>
           </p:cNvSpPr>
@@ -1076,7 +1101,7 @@
         <p:spPr>
           <a:xfrm>
             <a:off x="3884760" y="8685360"/>
-            <a:ext cx="2971440" cy="458280"/>
+            <a:ext cx="2971080" cy="457920"/>
           </a:xfrm>
           <a:prstGeom prst="rect">
             <a:avLst/>
@@ -1096,6 +1121,9 @@
                 <a:spcPct val="100000"/>
               </a:lnSpc>
               <a:buNone/>
+              <a:tabLst>
+                <a:tab algn="l" pos="0"/>
+              </a:tabLst>
               <a:defRPr b="0" lang="en-US" sz="1200" spc="-1" strike="noStrike">
                 <a:solidFill>
                   <a:schemeClr val="dk1"/>
@@ -1111,8 +1139,11 @@
                 <a:spcPct val="100000"/>
               </a:lnSpc>
               <a:buNone/>
-            </a:pPr>
-            <a:fld id="{D8CAF50D-4755-40C9-BA78-CE315CE69DAD}" type="slidenum">
+              <a:tabLst>
+                <a:tab algn="l" pos="0"/>
+              </a:tabLst>
+            </a:pPr>
+            <a:fld id="{9F296463-F5BA-43DF-9CE1-F270F8E0E77E}" type="slidenum">
               <a:rPr b="0" lang="en-US" sz="1200" spc="-1" strike="noStrike">
                 <a:solidFill>
                   <a:schemeClr val="dk1"/>
@@ -1155,7 +1186,7 @@
       </p:grpSpPr>
       <p:sp>
         <p:nvSpPr>
-          <p:cNvPr id="222" name="PlaceHolder 1"/>
+          <p:cNvPr id="226" name="PlaceHolder 1"/>
           <p:cNvSpPr>
             <a:spLocks noGrp="1"/>
           </p:cNvSpPr>
@@ -1166,19 +1197,19 @@
         <p:spPr>
           <a:xfrm>
             <a:off x="685800" y="1143000"/>
-            <a:ext cx="5486040" cy="3085920"/>
-          </a:xfrm>
-          <a:prstGeom prst="rect">
-            <a:avLst/>
-          </a:prstGeom>
-          <a:ln w="0">
-            <a:noFill/>
-          </a:ln>
-        </p:spPr>
-      </p:sp>
-      <p:sp>
-        <p:nvSpPr>
-          <p:cNvPr id="223" name="PlaceHolder 2"/>
+            <a:ext cx="5485680" cy="3085560"/>
+          </a:xfrm>
+          <a:prstGeom prst="rect">
+            <a:avLst/>
+          </a:prstGeom>
+          <a:ln w="0">
+            <a:noFill/>
+          </a:ln>
+        </p:spPr>
+      </p:sp>
+      <p:sp>
+        <p:nvSpPr>
+          <p:cNvPr id="227" name="PlaceHolder 2"/>
           <p:cNvSpPr>
             <a:spLocks noGrp="1"/>
           </p:cNvSpPr>
@@ -1189,7 +1220,7 @@
         <p:spPr>
           <a:xfrm>
             <a:off x="685800" y="4400640"/>
-            <a:ext cx="5486040" cy="3600000"/>
+            <a:ext cx="5485680" cy="3599640"/>
           </a:xfrm>
           <a:prstGeom prst="rect">
             <a:avLst/>
@@ -1218,7 +1249,7 @@
       </p:sp>
       <p:sp>
         <p:nvSpPr>
-          <p:cNvPr id="224" name="PlaceHolder 3"/>
+          <p:cNvPr id="228" name="PlaceHolder 3"/>
           <p:cNvSpPr>
             <a:spLocks noGrp="1"/>
           </p:cNvSpPr>
@@ -1229,7 +1260,7 @@
         <p:spPr>
           <a:xfrm>
             <a:off x="3884760" y="8685360"/>
-            <a:ext cx="2971440" cy="458280"/>
+            <a:ext cx="2971080" cy="457920"/>
           </a:xfrm>
           <a:prstGeom prst="rect">
             <a:avLst/>
@@ -1249,6 +1280,9 @@
                 <a:spcPct val="100000"/>
               </a:lnSpc>
               <a:buNone/>
+              <a:tabLst>
+                <a:tab algn="l" pos="0"/>
+              </a:tabLst>
               <a:defRPr b="0" lang="en-US" sz="1200" spc="-1" strike="noStrike">
                 <a:solidFill>
                   <a:schemeClr val="dk1"/>
@@ -1264,8 +1298,11 @@
                 <a:spcPct val="100000"/>
               </a:lnSpc>
               <a:buNone/>
-            </a:pPr>
-            <a:fld id="{C1DDCA95-8B74-4BA4-8DE1-C76F0B10FAAF}" type="slidenum">
+              <a:tabLst>
+                <a:tab algn="l" pos="0"/>
+              </a:tabLst>
+            </a:pPr>
+            <a:fld id="{3D817AF2-FD32-4ADE-9082-F2F098D87BE7}" type="slidenum">
               <a:rPr b="0" lang="en-US" sz="1200" spc="-1" strike="noStrike">
                 <a:solidFill>
                   <a:schemeClr val="dk1"/>
@@ -1308,7 +1345,7 @@
       </p:grpSpPr>
       <p:sp>
         <p:nvSpPr>
-          <p:cNvPr id="225" name="PlaceHolder 1"/>
+          <p:cNvPr id="229" name="PlaceHolder 1"/>
           <p:cNvSpPr>
             <a:spLocks noGrp="1"/>
           </p:cNvSpPr>
@@ -1319,19 +1356,19 @@
         <p:spPr>
           <a:xfrm>
             <a:off x="685800" y="1143000"/>
-            <a:ext cx="5486040" cy="3085920"/>
-          </a:xfrm>
-          <a:prstGeom prst="rect">
-            <a:avLst/>
-          </a:prstGeom>
-          <a:ln w="0">
-            <a:noFill/>
-          </a:ln>
-        </p:spPr>
-      </p:sp>
-      <p:sp>
-        <p:nvSpPr>
-          <p:cNvPr id="226" name="PlaceHolder 2"/>
+            <a:ext cx="5485680" cy="3085560"/>
+          </a:xfrm>
+          <a:prstGeom prst="rect">
+            <a:avLst/>
+          </a:prstGeom>
+          <a:ln w="0">
+            <a:noFill/>
+          </a:ln>
+        </p:spPr>
+      </p:sp>
+      <p:sp>
+        <p:nvSpPr>
+          <p:cNvPr id="230" name="PlaceHolder 2"/>
           <p:cNvSpPr>
             <a:spLocks noGrp="1"/>
           </p:cNvSpPr>
@@ -1342,7 +1379,7 @@
         <p:spPr>
           <a:xfrm>
             <a:off x="685800" y="4400640"/>
-            <a:ext cx="5486040" cy="3600000"/>
+            <a:ext cx="5485680" cy="3599640"/>
           </a:xfrm>
           <a:prstGeom prst="rect">
             <a:avLst/>
@@ -1371,7 +1408,7 @@
       </p:sp>
       <p:sp>
         <p:nvSpPr>
-          <p:cNvPr id="227" name="PlaceHolder 3"/>
+          <p:cNvPr id="231" name="PlaceHolder 3"/>
           <p:cNvSpPr>
             <a:spLocks noGrp="1"/>
           </p:cNvSpPr>
@@ -1382,7 +1419,7 @@
         <p:spPr>
           <a:xfrm>
             <a:off x="3884760" y="8685360"/>
-            <a:ext cx="2971440" cy="458280"/>
+            <a:ext cx="2971080" cy="457920"/>
           </a:xfrm>
           <a:prstGeom prst="rect">
             <a:avLst/>
@@ -1402,6 +1439,9 @@
                 <a:spcPct val="100000"/>
               </a:lnSpc>
               <a:buNone/>
+              <a:tabLst>
+                <a:tab algn="l" pos="0"/>
+              </a:tabLst>
               <a:defRPr b="0" lang="en-US" sz="1200" spc="-1" strike="noStrike">
                 <a:solidFill>
                   <a:schemeClr val="dk1"/>
@@ -1417,8 +1457,11 @@
                 <a:spcPct val="100000"/>
               </a:lnSpc>
               <a:buNone/>
-            </a:pPr>
-            <a:fld id="{A3EF18E7-AB5F-479C-9882-07843F2BB2F5}" type="slidenum">
+              <a:tabLst>
+                <a:tab algn="l" pos="0"/>
+              </a:tabLst>
+            </a:pPr>
+            <a:fld id="{D23F819D-6F0A-4AB4-90DB-B4BD22879BCF}" type="slidenum">
               <a:rPr b="0" lang="en-US" sz="1200" spc="-1" strike="noStrike">
                 <a:solidFill>
                   <a:schemeClr val="dk1"/>
@@ -1461,7 +1504,7 @@
       </p:grpSpPr>
       <p:sp>
         <p:nvSpPr>
-          <p:cNvPr id="228" name="PlaceHolder 1"/>
+          <p:cNvPr id="232" name="PlaceHolder 1"/>
           <p:cNvSpPr>
             <a:spLocks noGrp="1"/>
           </p:cNvSpPr>
@@ -1472,19 +1515,19 @@
         <p:spPr>
           <a:xfrm>
             <a:off x="685800" y="1143000"/>
-            <a:ext cx="5486040" cy="3085920"/>
-          </a:xfrm>
-          <a:prstGeom prst="rect">
-            <a:avLst/>
-          </a:prstGeom>
-          <a:ln w="0">
-            <a:noFill/>
-          </a:ln>
-        </p:spPr>
-      </p:sp>
-      <p:sp>
-        <p:nvSpPr>
-          <p:cNvPr id="229" name="PlaceHolder 2"/>
+            <a:ext cx="5485680" cy="3085560"/>
+          </a:xfrm>
+          <a:prstGeom prst="rect">
+            <a:avLst/>
+          </a:prstGeom>
+          <a:ln w="0">
+            <a:noFill/>
+          </a:ln>
+        </p:spPr>
+      </p:sp>
+      <p:sp>
+        <p:nvSpPr>
+          <p:cNvPr id="233" name="PlaceHolder 2"/>
           <p:cNvSpPr>
             <a:spLocks noGrp="1"/>
           </p:cNvSpPr>
@@ -1495,7 +1538,7 @@
         <p:spPr>
           <a:xfrm>
             <a:off x="685800" y="4400640"/>
-            <a:ext cx="5486040" cy="3600000"/>
+            <a:ext cx="5485680" cy="3599640"/>
           </a:xfrm>
           <a:prstGeom prst="rect">
             <a:avLst/>
@@ -1524,7 +1567,7 @@
       </p:sp>
       <p:sp>
         <p:nvSpPr>
-          <p:cNvPr id="230" name="PlaceHolder 3"/>
+          <p:cNvPr id="234" name="PlaceHolder 3"/>
           <p:cNvSpPr>
             <a:spLocks noGrp="1"/>
           </p:cNvSpPr>
@@ -1535,7 +1578,7 @@
         <p:spPr>
           <a:xfrm>
             <a:off x="3884760" y="8685360"/>
-            <a:ext cx="2971440" cy="458280"/>
+            <a:ext cx="2971080" cy="457920"/>
           </a:xfrm>
           <a:prstGeom prst="rect">
             <a:avLst/>
@@ -1555,6 +1598,9 @@
                 <a:spcPct val="100000"/>
               </a:lnSpc>
               <a:buNone/>
+              <a:tabLst>
+                <a:tab algn="l" pos="0"/>
+              </a:tabLst>
               <a:defRPr b="0" lang="en-US" sz="1200" spc="-1" strike="noStrike">
                 <a:solidFill>
                   <a:schemeClr val="dk1"/>
@@ -1570,8 +1616,11 @@
                 <a:spcPct val="100000"/>
               </a:lnSpc>
               <a:buNone/>
-            </a:pPr>
-            <a:fld id="{565AF2E9-56C6-4498-A178-E55561EA6BBB}" type="slidenum">
+              <a:tabLst>
+                <a:tab algn="l" pos="0"/>
+              </a:tabLst>
+            </a:pPr>
+            <a:fld id="{D5294324-1034-43C3-BF69-48DC9101F8C8}" type="slidenum">
               <a:rPr b="0" lang="en-US" sz="1200" spc="-1" strike="noStrike">
                 <a:solidFill>
                   <a:schemeClr val="dk1"/>
@@ -1614,7 +1663,7 @@
       </p:grpSpPr>
       <p:sp>
         <p:nvSpPr>
-          <p:cNvPr id="231" name="PlaceHolder 1"/>
+          <p:cNvPr id="235" name="PlaceHolder 1"/>
           <p:cNvSpPr>
             <a:spLocks noGrp="1"/>
           </p:cNvSpPr>
@@ -1625,19 +1674,19 @@
         <p:spPr>
           <a:xfrm>
             <a:off x="685800" y="1143000"/>
-            <a:ext cx="5486040" cy="3085920"/>
-          </a:xfrm>
-          <a:prstGeom prst="rect">
-            <a:avLst/>
-          </a:prstGeom>
-          <a:ln w="0">
-            <a:noFill/>
-          </a:ln>
-        </p:spPr>
-      </p:sp>
-      <p:sp>
-        <p:nvSpPr>
-          <p:cNvPr id="232" name="PlaceHolder 2"/>
+            <a:ext cx="5485680" cy="3085560"/>
+          </a:xfrm>
+          <a:prstGeom prst="rect">
+            <a:avLst/>
+          </a:prstGeom>
+          <a:ln w="0">
+            <a:noFill/>
+          </a:ln>
+        </p:spPr>
+      </p:sp>
+      <p:sp>
+        <p:nvSpPr>
+          <p:cNvPr id="236" name="PlaceHolder 2"/>
           <p:cNvSpPr>
             <a:spLocks noGrp="1"/>
           </p:cNvSpPr>
@@ -1648,7 +1697,7 @@
         <p:spPr>
           <a:xfrm>
             <a:off x="685800" y="4400640"/>
-            <a:ext cx="5486040" cy="3600000"/>
+            <a:ext cx="5485680" cy="3599640"/>
           </a:xfrm>
           <a:prstGeom prst="rect">
             <a:avLst/>
@@ -1677,7 +1726,7 @@
       </p:sp>
       <p:sp>
         <p:nvSpPr>
-          <p:cNvPr id="233" name="PlaceHolder 3"/>
+          <p:cNvPr id="237" name="PlaceHolder 3"/>
           <p:cNvSpPr>
             <a:spLocks noGrp="1"/>
           </p:cNvSpPr>
@@ -1688,7 +1737,7 @@
         <p:spPr>
           <a:xfrm>
             <a:off x="3884760" y="8685360"/>
-            <a:ext cx="2971440" cy="458280"/>
+            <a:ext cx="2971080" cy="457920"/>
           </a:xfrm>
           <a:prstGeom prst="rect">
             <a:avLst/>
@@ -1708,6 +1757,9 @@
                 <a:spcPct val="100000"/>
               </a:lnSpc>
               <a:buNone/>
+              <a:tabLst>
+                <a:tab algn="l" pos="0"/>
+              </a:tabLst>
               <a:defRPr b="0" lang="en-US" sz="1200" spc="-1" strike="noStrike">
                 <a:solidFill>
                   <a:schemeClr val="dk1"/>
@@ -1723,8 +1775,11 @@
                 <a:spcPct val="100000"/>
               </a:lnSpc>
               <a:buNone/>
-            </a:pPr>
-            <a:fld id="{449AA029-6FF6-45FC-8026-2812B683539C}" type="slidenum">
+              <a:tabLst>
+                <a:tab algn="l" pos="0"/>
+              </a:tabLst>
+            </a:pPr>
+            <a:fld id="{506DCCEA-097C-4B82-8B2A-717D216E8C2A}" type="slidenum">
               <a:rPr b="0" lang="en-US" sz="1200" spc="-1" strike="noStrike">
                 <a:solidFill>
                   <a:schemeClr val="dk1"/>
@@ -1767,7 +1822,7 @@
       </p:grpSpPr>
       <p:sp>
         <p:nvSpPr>
-          <p:cNvPr id="234" name="PlaceHolder 1"/>
+          <p:cNvPr id="238" name="PlaceHolder 1"/>
           <p:cNvSpPr>
             <a:spLocks noGrp="1"/>
           </p:cNvSpPr>
@@ -1778,19 +1833,19 @@
         <p:spPr>
           <a:xfrm>
             <a:off x="685800" y="1143000"/>
-            <a:ext cx="5486040" cy="3085920"/>
-          </a:xfrm>
-          <a:prstGeom prst="rect">
-            <a:avLst/>
-          </a:prstGeom>
-          <a:ln w="0">
-            <a:noFill/>
-          </a:ln>
-        </p:spPr>
-      </p:sp>
-      <p:sp>
-        <p:nvSpPr>
-          <p:cNvPr id="235" name="PlaceHolder 2"/>
+            <a:ext cx="5485680" cy="3085560"/>
+          </a:xfrm>
+          <a:prstGeom prst="rect">
+            <a:avLst/>
+          </a:prstGeom>
+          <a:ln w="0">
+            <a:noFill/>
+          </a:ln>
+        </p:spPr>
+      </p:sp>
+      <p:sp>
+        <p:nvSpPr>
+          <p:cNvPr id="239" name="PlaceHolder 2"/>
           <p:cNvSpPr>
             <a:spLocks noGrp="1"/>
           </p:cNvSpPr>
@@ -1801,7 +1856,7 @@
         <p:spPr>
           <a:xfrm>
             <a:off x="685800" y="4400640"/>
-            <a:ext cx="5486040" cy="3600000"/>
+            <a:ext cx="5485680" cy="3599640"/>
           </a:xfrm>
           <a:prstGeom prst="rect">
             <a:avLst/>
@@ -1830,7 +1885,7 @@
       </p:sp>
       <p:sp>
         <p:nvSpPr>
-          <p:cNvPr id="236" name="PlaceHolder 3"/>
+          <p:cNvPr id="240" name="PlaceHolder 3"/>
           <p:cNvSpPr>
             <a:spLocks noGrp="1"/>
           </p:cNvSpPr>
@@ -1841,7 +1896,7 @@
         <p:spPr>
           <a:xfrm>
             <a:off x="3884760" y="8685360"/>
-            <a:ext cx="2971440" cy="458280"/>
+            <a:ext cx="2971080" cy="457920"/>
           </a:xfrm>
           <a:prstGeom prst="rect">
             <a:avLst/>
@@ -1861,6 +1916,9 @@
                 <a:spcPct val="100000"/>
               </a:lnSpc>
               <a:buNone/>
+              <a:tabLst>
+                <a:tab algn="l" pos="0"/>
+              </a:tabLst>
               <a:defRPr b="0" lang="en-US" sz="1200" spc="-1" strike="noStrike">
                 <a:solidFill>
                   <a:schemeClr val="dk1"/>
@@ -1876,8 +1934,11 @@
                 <a:spcPct val="100000"/>
               </a:lnSpc>
               <a:buNone/>
-            </a:pPr>
-            <a:fld id="{944072D7-FBDB-4898-91F0-BD71A553F299}" type="slidenum">
+              <a:tabLst>
+                <a:tab algn="l" pos="0"/>
+              </a:tabLst>
+            </a:pPr>
+            <a:fld id="{88AA8D00-0246-475B-ACA9-F8C4B8F621CB}" type="slidenum">
               <a:rPr b="0" lang="en-US" sz="1200" spc="-1" strike="noStrike">
                 <a:solidFill>
                   <a:schemeClr val="dk1"/>
@@ -1975,23 +2036,32 @@
             <a:noAutofit/>
           </a:bodyPr>
           <a:p>
-            <a:pPr indent="0">
+            <a:pPr indent="0" algn="ctr">
               <a:buNone/>
             </a:pPr>
             <a:r>
-              <a:rPr b="0" lang="en-US" sz="1800" spc="-1" strike="noStrike">
-                <a:solidFill>
-                  <a:schemeClr val="dk1"/>
-                </a:solidFill>
-                <a:latin typeface="Calibri"/>
-              </a:rPr>
-              <a:t>Click to edit the title text format</a:t>
-            </a:r>
-            <a:endParaRPr b="0" lang="en-US" sz="1800" spc="-1" strike="noStrike">
-              <a:solidFill>
-                <a:schemeClr val="dk1"/>
-              </a:solidFill>
-              <a:latin typeface="Calibri"/>
+              <a:rPr b="0" lang="en-US" sz="4400" spc="-1" strike="noStrike">
+                <a:solidFill>
+                  <a:srgbClr val="000000"/>
+                </a:solidFill>
+                <a:latin typeface="Arial"/>
+              </a:rPr>
+              <a:t>Click to edit the title text </a:t>
+            </a:r>
+            <a:r>
+              <a:rPr b="0" lang="en-US" sz="4400" spc="-1" strike="noStrike">
+                <a:solidFill>
+                  <a:srgbClr val="000000"/>
+                </a:solidFill>
+                <a:latin typeface="Arial"/>
+              </a:rPr>
+              <a:t>format</a:t>
+            </a:r>
+            <a:endParaRPr b="0" lang="en-US" sz="4400" spc="-1" strike="noStrike">
+              <a:solidFill>
+                <a:srgbClr val="000000"/>
+              </a:solidFill>
+              <a:latin typeface="Arial"/>
             </a:endParaRPr>
           </a:p>
         </p:txBody>
@@ -2038,17 +2108,17 @@
             <a:r>
               <a:rPr b="0" lang="en-US" sz="3200" spc="-1" strike="noStrike">
                 <a:solidFill>
-                  <a:schemeClr val="dk1"/>
-                </a:solidFill>
-                <a:latin typeface="Calibri"/>
+                  <a:srgbClr val="000000"/>
+                </a:solidFill>
+                <a:latin typeface="Arial"/>
               </a:rPr>
               <a:t>Click to edit the outline text format</a:t>
             </a:r>
             <a:endParaRPr b="0" lang="en-US" sz="3200" spc="-1" strike="noStrike">
               <a:solidFill>
-                <a:schemeClr val="dk1"/>
-              </a:solidFill>
-              <a:latin typeface="Calibri"/>
+                <a:srgbClr val="000000"/>
+              </a:solidFill>
+              <a:latin typeface="Arial"/>
             </a:endParaRPr>
           </a:p>
           <a:p>
@@ -2064,19 +2134,19 @@
               <a:buChar char=""/>
             </a:pPr>
             <a:r>
-              <a:rPr b="0" lang="en-US" sz="2400" spc="-1" strike="noStrike">
-                <a:solidFill>
-                  <a:schemeClr val="dk1"/>
-                </a:solidFill>
-                <a:latin typeface="Calibri"/>
+              <a:rPr b="0" lang="en-US" sz="2800" spc="-1" strike="noStrike">
+                <a:solidFill>
+                  <a:srgbClr val="000000"/>
+                </a:solidFill>
+                <a:latin typeface="Arial"/>
               </a:rPr>
               <a:t>Second Outline Level</a:t>
             </a:r>
-            <a:endParaRPr b="0" lang="en-US" sz="2400" spc="-1" strike="noStrike">
-              <a:solidFill>
-                <a:schemeClr val="dk1"/>
-              </a:solidFill>
-              <a:latin typeface="Calibri"/>
+            <a:endParaRPr b="0" lang="en-US" sz="2800" spc="-1" strike="noStrike">
+              <a:solidFill>
+                <a:srgbClr val="000000"/>
+              </a:solidFill>
+              <a:latin typeface="Arial"/>
             </a:endParaRPr>
           </a:p>
           <a:p>
@@ -2092,19 +2162,19 @@
               <a:buChar char=""/>
             </a:pPr>
             <a:r>
-              <a:rPr b="0" lang="en-US" sz="2000" spc="-1" strike="noStrike">
-                <a:solidFill>
-                  <a:schemeClr val="dk1"/>
-                </a:solidFill>
-                <a:latin typeface="Calibri"/>
+              <a:rPr b="0" lang="en-US" sz="2400" spc="-1" strike="noStrike">
+                <a:solidFill>
+                  <a:srgbClr val="000000"/>
+                </a:solidFill>
+                <a:latin typeface="Arial"/>
               </a:rPr>
               <a:t>Third Outline Level</a:t>
             </a:r>
-            <a:endParaRPr b="0" lang="en-US" sz="2000" spc="-1" strike="noStrike">
-              <a:solidFill>
-                <a:schemeClr val="dk1"/>
-              </a:solidFill>
-              <a:latin typeface="Calibri"/>
+            <a:endParaRPr b="0" lang="en-US" sz="2400" spc="-1" strike="noStrike">
+              <a:solidFill>
+                <a:srgbClr val="000000"/>
+              </a:solidFill>
+              <a:latin typeface="Arial"/>
             </a:endParaRPr>
           </a:p>
           <a:p>
@@ -2122,17 +2192,17 @@
             <a:r>
               <a:rPr b="0" lang="en-US" sz="2000" spc="-1" strike="noStrike">
                 <a:solidFill>
-                  <a:schemeClr val="dk1"/>
-                </a:solidFill>
-                <a:latin typeface="Calibri"/>
+                  <a:srgbClr val="000000"/>
+                </a:solidFill>
+                <a:latin typeface="Arial"/>
               </a:rPr>
               <a:t>Fourth Outline Level</a:t>
             </a:r>
             <a:endParaRPr b="0" lang="en-US" sz="2000" spc="-1" strike="noStrike">
               <a:solidFill>
-                <a:schemeClr val="dk1"/>
-              </a:solidFill>
-              <a:latin typeface="Calibri"/>
+                <a:srgbClr val="000000"/>
+              </a:solidFill>
+              <a:latin typeface="Arial"/>
             </a:endParaRPr>
           </a:p>
           <a:p>
@@ -2150,17 +2220,17 @@
             <a:r>
               <a:rPr b="0" lang="en-US" sz="2000" spc="-1" strike="noStrike">
                 <a:solidFill>
-                  <a:schemeClr val="dk1"/>
-                </a:solidFill>
-                <a:latin typeface="Calibri"/>
+                  <a:srgbClr val="000000"/>
+                </a:solidFill>
+                <a:latin typeface="Arial"/>
               </a:rPr>
               <a:t>Fifth Outline Level</a:t>
             </a:r>
             <a:endParaRPr b="0" lang="en-US" sz="2000" spc="-1" strike="noStrike">
               <a:solidFill>
-                <a:schemeClr val="dk1"/>
-              </a:solidFill>
-              <a:latin typeface="Calibri"/>
+                <a:srgbClr val="000000"/>
+              </a:solidFill>
+              <a:latin typeface="Arial"/>
             </a:endParaRPr>
           </a:p>
           <a:p>
@@ -2178,17 +2248,17 @@
             <a:r>
               <a:rPr b="0" lang="en-US" sz="2000" spc="-1" strike="noStrike">
                 <a:solidFill>
-                  <a:schemeClr val="dk1"/>
-                </a:solidFill>
-                <a:latin typeface="Calibri"/>
+                  <a:srgbClr val="000000"/>
+                </a:solidFill>
+                <a:latin typeface="Arial"/>
               </a:rPr>
               <a:t>Sixth Outline Level</a:t>
             </a:r>
             <a:endParaRPr b="0" lang="en-US" sz="2000" spc="-1" strike="noStrike">
               <a:solidFill>
-                <a:schemeClr val="dk1"/>
-              </a:solidFill>
-              <a:latin typeface="Calibri"/>
+                <a:srgbClr val="000000"/>
+              </a:solidFill>
+              <a:latin typeface="Arial"/>
             </a:endParaRPr>
           </a:p>
           <a:p>
@@ -2206,17 +2276,17 @@
             <a:r>
               <a:rPr b="0" lang="en-US" sz="2000" spc="-1" strike="noStrike">
                 <a:solidFill>
-                  <a:schemeClr val="dk1"/>
-                </a:solidFill>
-                <a:latin typeface="Calibri"/>
+                  <a:srgbClr val="000000"/>
+                </a:solidFill>
+                <a:latin typeface="Arial"/>
               </a:rPr>
               <a:t>Seventh Outline Level</a:t>
             </a:r>
             <a:endParaRPr b="0" lang="en-US" sz="2000" spc="-1" strike="noStrike">
               <a:solidFill>
-                <a:schemeClr val="dk1"/>
-              </a:solidFill>
-              <a:latin typeface="Calibri"/>
+                <a:srgbClr val="000000"/>
+              </a:solidFill>
+              <a:latin typeface="Arial"/>
             </a:endParaRPr>
           </a:p>
         </p:txBody>
@@ -2263,7 +2333,7 @@
         <p:spPr>
           <a:xfrm>
             <a:off x="9692640" y="-1280160"/>
-            <a:ext cx="4114440" cy="4114440"/>
+            <a:ext cx="4114080" cy="4114080"/>
           </a:xfrm>
           <a:prstGeom prst="ellipse">
             <a:avLst/>
@@ -2288,6 +2358,11 @@
             <a:noAutofit/>
           </a:bodyPr>
           <a:p>
+            <a:pPr>
+              <a:lnSpc>
+                <a:spcPct val="100000"/>
+              </a:lnSpc>
+            </a:pPr>
             <a:endParaRPr b="0" lang="en-US" sz="1800" spc="-1" strike="noStrike">
               <a:solidFill>
                 <a:srgbClr val="ffffff"/>
@@ -2306,7 +2381,7 @@
         <p:spPr>
           <a:xfrm>
             <a:off x="10607040" y="4206240"/>
-            <a:ext cx="2925720" cy="2925720"/>
+            <a:ext cx="2925360" cy="2925360"/>
           </a:xfrm>
           <a:prstGeom prst="ellipse">
             <a:avLst/>
@@ -2331,6 +2406,11 @@
             <a:noAutofit/>
           </a:bodyPr>
           <a:p>
+            <a:pPr>
+              <a:lnSpc>
+                <a:spcPct val="100000"/>
+              </a:lnSpc>
+            </a:pPr>
             <a:endParaRPr b="0" lang="en-US" sz="1800" spc="-1" strike="noStrike">
               <a:solidFill>
                 <a:srgbClr val="ffffff"/>
@@ -2349,7 +2429,7 @@
         <p:spPr>
           <a:xfrm>
             <a:off x="731520" y="1417320"/>
-            <a:ext cx="9143640" cy="365400"/>
+            <a:ext cx="9143280" cy="365040"/>
           </a:xfrm>
           <a:prstGeom prst="rect">
             <a:avLst/>
@@ -2379,7 +2459,7 @@
               </a:tabLst>
             </a:pPr>
             <a:r>
-              <a:rPr b="1" lang="en-US" sz="1300" spc="199" strike="noStrike">
+              <a:rPr b="1" lang="en-US" sz="1300" spc="197" strike="noStrike">
                 <a:solidFill>
                   <a:srgbClr val="02c39a"/>
                 </a:solidFill>
@@ -2406,7 +2486,7 @@
         <p:spPr>
           <a:xfrm>
             <a:off x="731520" y="1874520"/>
-            <a:ext cx="9875160" cy="1828440"/>
+            <a:ext cx="9874800" cy="1828080"/>
           </a:xfrm>
           <a:prstGeom prst="rect">
             <a:avLst/>
@@ -2489,7 +2569,7 @@
         <p:spPr>
           <a:xfrm>
             <a:off x="731520" y="3703320"/>
-            <a:ext cx="9600840" cy="548280"/>
+            <a:ext cx="9600480" cy="547920"/>
           </a:xfrm>
           <a:prstGeom prst="rect">
             <a:avLst/>
@@ -2587,7 +2667,7 @@
         <p:spPr>
           <a:xfrm>
             <a:off x="731520" y="4663440"/>
-            <a:ext cx="10515240" cy="456840"/>
+            <a:ext cx="10514880" cy="456480"/>
           </a:xfrm>
           <a:prstGeom prst="rect">
             <a:avLst/>
@@ -2644,7 +2724,7 @@
         <p:spPr>
           <a:xfrm>
             <a:off x="731520" y="5074920"/>
-            <a:ext cx="10515240" cy="365400"/>
+            <a:ext cx="10514880" cy="365040"/>
           </a:xfrm>
           <a:prstGeom prst="rect">
             <a:avLst/>
@@ -2731,14 +2811,14 @@
       </p:grpSpPr>
       <p:sp>
         <p:nvSpPr>
-          <p:cNvPr id="176" name="Text 0"/>
+          <p:cNvPr id="180" name="Text 0"/>
           <p:cNvSpPr/>
           <p:nvPr/>
         </p:nvSpPr>
         <p:spPr>
           <a:xfrm>
             <a:off x="548640" y="384120"/>
-            <a:ext cx="7314840" cy="319680"/>
+            <a:ext cx="7314480" cy="319320"/>
           </a:xfrm>
           <a:prstGeom prst="rect">
             <a:avLst/>
@@ -2768,7 +2848,7 @@
               </a:tabLst>
             </a:pPr>
             <a:r>
-              <a:rPr b="1" lang="en-US" sz="1300" spc="199" strike="noStrike">
+              <a:rPr b="1" lang="en-US" sz="1300" spc="197" strike="noStrike">
                 <a:solidFill>
                   <a:srgbClr val="028090"/>
                 </a:solidFill>
@@ -2788,14 +2868,14 @@
       </p:sp>
       <p:sp>
         <p:nvSpPr>
-          <p:cNvPr id="177" name="Text 1"/>
+          <p:cNvPr id="181" name="Text 1"/>
           <p:cNvSpPr/>
           <p:nvPr/>
         </p:nvSpPr>
         <p:spPr>
           <a:xfrm>
             <a:off x="548640" y="658440"/>
-            <a:ext cx="11063880" cy="822600"/>
+            <a:ext cx="11063520" cy="822240"/>
           </a:xfrm>
           <a:prstGeom prst="rect">
             <a:avLst/>
@@ -2845,14 +2925,14 @@
       </p:sp>
       <p:sp>
         <p:nvSpPr>
-          <p:cNvPr id="178" name="Text 2"/>
+          <p:cNvPr id="182" name="Text 2"/>
           <p:cNvSpPr/>
           <p:nvPr/>
         </p:nvSpPr>
         <p:spPr>
           <a:xfrm>
             <a:off x="548640" y="1508760"/>
-            <a:ext cx="10881000" cy="639720"/>
+            <a:ext cx="10880640" cy="639360"/>
           </a:xfrm>
           <a:prstGeom prst="rect">
             <a:avLst/>
@@ -2902,14 +2982,14 @@
       </p:sp>
       <p:sp>
         <p:nvSpPr>
-          <p:cNvPr id="179" name="Shape 3"/>
+          <p:cNvPr id="183" name="Shape 3"/>
           <p:cNvSpPr/>
           <p:nvPr/>
         </p:nvSpPr>
         <p:spPr>
           <a:xfrm>
             <a:off x="548640" y="2331720"/>
-            <a:ext cx="3501720" cy="1535760"/>
+            <a:ext cx="3501360" cy="1535400"/>
           </a:xfrm>
           <a:prstGeom prst="roundRect">
             <a:avLst>
@@ -2944,6 +3024,11 @@
             <a:noAutofit/>
           </a:bodyPr>
           <a:p>
+            <a:pPr>
+              <a:lnSpc>
+                <a:spcPct val="100000"/>
+              </a:lnSpc>
+            </a:pPr>
             <a:endParaRPr b="0" lang="en-US" sz="1800" spc="-1" strike="noStrike">
               <a:solidFill>
                 <a:srgbClr val="000000"/>
@@ -2955,14 +3040,14 @@
       </p:sp>
       <p:sp>
         <p:nvSpPr>
-          <p:cNvPr id="180" name="Shape 4"/>
+          <p:cNvPr id="184" name="Shape 4"/>
           <p:cNvSpPr/>
           <p:nvPr/>
         </p:nvSpPr>
         <p:spPr>
           <a:xfrm>
             <a:off x="749880" y="2532960"/>
-            <a:ext cx="383760" cy="383760"/>
+            <a:ext cx="383400" cy="383400"/>
           </a:xfrm>
           <a:prstGeom prst="roundRect">
             <a:avLst>
@@ -2989,6 +3074,11 @@
             <a:noAutofit/>
           </a:bodyPr>
           <a:p>
+            <a:pPr>
+              <a:lnSpc>
+                <a:spcPct val="100000"/>
+              </a:lnSpc>
+            </a:pPr>
             <a:endParaRPr b="0" lang="en-US" sz="1800" spc="-1" strike="noStrike">
               <a:solidFill>
                 <a:srgbClr val="ffffff"/>
@@ -3000,14 +3090,14 @@
       </p:sp>
       <p:sp>
         <p:nvSpPr>
-          <p:cNvPr id="181" name="Shape 5"/>
+          <p:cNvPr id="185" name="Shape 5"/>
           <p:cNvSpPr/>
           <p:nvPr/>
         </p:nvSpPr>
         <p:spPr>
           <a:xfrm>
             <a:off x="877680" y="2660760"/>
-            <a:ext cx="127800" cy="127800"/>
+            <a:ext cx="127440" cy="127440"/>
           </a:xfrm>
           <a:prstGeom prst="ellipse">
             <a:avLst/>
@@ -3030,6 +3120,11 @@
             <a:noAutofit/>
           </a:bodyPr>
           <a:p>
+            <a:pPr>
+              <a:lnSpc>
+                <a:spcPct val="100000"/>
+              </a:lnSpc>
+            </a:pPr>
             <a:endParaRPr b="0" lang="en-US" sz="1800" spc="-1" strike="noStrike">
               <a:solidFill>
                 <a:srgbClr val="ffffff"/>
@@ -3041,14 +3136,14 @@
       </p:sp>
       <p:sp>
         <p:nvSpPr>
-          <p:cNvPr id="182" name="Text 6"/>
+          <p:cNvPr id="186" name="Text 6"/>
           <p:cNvSpPr/>
           <p:nvPr/>
         </p:nvSpPr>
         <p:spPr>
           <a:xfrm>
             <a:off x="749880" y="3008520"/>
-            <a:ext cx="3099600" cy="310680"/>
+            <a:ext cx="3099240" cy="310320"/>
           </a:xfrm>
           <a:prstGeom prst="rect">
             <a:avLst/>
@@ -3098,14 +3193,14 @@
       </p:sp>
       <p:sp>
         <p:nvSpPr>
-          <p:cNvPr id="183" name="Text 7"/>
+          <p:cNvPr id="187" name="Text 7"/>
           <p:cNvSpPr/>
           <p:nvPr/>
         </p:nvSpPr>
         <p:spPr>
           <a:xfrm>
             <a:off x="749880" y="3300840"/>
-            <a:ext cx="3099600" cy="475200"/>
+            <a:ext cx="3099240" cy="474840"/>
           </a:xfrm>
           <a:prstGeom prst="rect">
             <a:avLst/>
@@ -3155,14 +3250,14 @@
       </p:sp>
       <p:sp>
         <p:nvSpPr>
-          <p:cNvPr id="184" name="Shape 8"/>
+          <p:cNvPr id="188" name="Shape 8"/>
           <p:cNvSpPr/>
           <p:nvPr/>
         </p:nvSpPr>
         <p:spPr>
           <a:xfrm>
             <a:off x="4325040" y="2331720"/>
-            <a:ext cx="3501720" cy="1535760"/>
+            <a:ext cx="3501360" cy="1535400"/>
           </a:xfrm>
           <a:prstGeom prst="roundRect">
             <a:avLst>
@@ -3197,6 +3292,11 @@
             <a:noAutofit/>
           </a:bodyPr>
           <a:p>
+            <a:pPr>
+              <a:lnSpc>
+                <a:spcPct val="100000"/>
+              </a:lnSpc>
+            </a:pPr>
             <a:endParaRPr b="0" lang="en-US" sz="1800" spc="-1" strike="noStrike">
               <a:solidFill>
                 <a:srgbClr val="000000"/>
@@ -3208,14 +3308,14 @@
       </p:sp>
       <p:sp>
         <p:nvSpPr>
-          <p:cNvPr id="185" name="Shape 9"/>
+          <p:cNvPr id="189" name="Shape 9"/>
           <p:cNvSpPr/>
           <p:nvPr/>
         </p:nvSpPr>
         <p:spPr>
           <a:xfrm>
             <a:off x="4526280" y="2532960"/>
-            <a:ext cx="383760" cy="383760"/>
+            <a:ext cx="383400" cy="383400"/>
           </a:xfrm>
           <a:prstGeom prst="roundRect">
             <a:avLst>
@@ -3242,6 +3342,11 @@
             <a:noAutofit/>
           </a:bodyPr>
           <a:p>
+            <a:pPr>
+              <a:lnSpc>
+                <a:spcPct val="100000"/>
+              </a:lnSpc>
+            </a:pPr>
             <a:endParaRPr b="0" lang="en-US" sz="1800" spc="-1" strike="noStrike">
               <a:solidFill>
                 <a:srgbClr val="ffffff"/>
@@ -3253,14 +3358,14 @@
       </p:sp>
       <p:sp>
         <p:nvSpPr>
-          <p:cNvPr id="186" name="Shape 10"/>
+          <p:cNvPr id="190" name="Shape 10"/>
           <p:cNvSpPr/>
           <p:nvPr/>
         </p:nvSpPr>
         <p:spPr>
           <a:xfrm>
             <a:off x="4654440" y="2660760"/>
-            <a:ext cx="127800" cy="127800"/>
+            <a:ext cx="127440" cy="127440"/>
           </a:xfrm>
           <a:prstGeom prst="ellipse">
             <a:avLst/>
@@ -3283,6 +3388,11 @@
             <a:noAutofit/>
           </a:bodyPr>
           <a:p>
+            <a:pPr>
+              <a:lnSpc>
+                <a:spcPct val="100000"/>
+              </a:lnSpc>
+            </a:pPr>
             <a:endParaRPr b="0" lang="en-US" sz="1800" spc="-1" strike="noStrike">
               <a:solidFill>
                 <a:srgbClr val="ffffff"/>
@@ -3294,14 +3404,14 @@
       </p:sp>
       <p:sp>
         <p:nvSpPr>
-          <p:cNvPr id="187" name="Text 11"/>
+          <p:cNvPr id="191" name="Text 11"/>
           <p:cNvSpPr/>
           <p:nvPr/>
         </p:nvSpPr>
         <p:spPr>
           <a:xfrm>
             <a:off x="4526280" y="3008520"/>
-            <a:ext cx="3099600" cy="310680"/>
+            <a:ext cx="3099240" cy="310320"/>
           </a:xfrm>
           <a:prstGeom prst="rect">
             <a:avLst/>
@@ -3351,14 +3461,14 @@
       </p:sp>
       <p:sp>
         <p:nvSpPr>
-          <p:cNvPr id="188" name="Text 12"/>
+          <p:cNvPr id="192" name="Text 12"/>
           <p:cNvSpPr/>
           <p:nvPr/>
         </p:nvSpPr>
         <p:spPr>
           <a:xfrm>
             <a:off x="4526280" y="3300840"/>
-            <a:ext cx="3099600" cy="475200"/>
+            <a:ext cx="3099240" cy="474840"/>
           </a:xfrm>
           <a:prstGeom prst="rect">
             <a:avLst/>
@@ -3408,14 +3518,14 @@
       </p:sp>
       <p:sp>
         <p:nvSpPr>
-          <p:cNvPr id="189" name="Shape 13"/>
+          <p:cNvPr id="193" name="Shape 13"/>
           <p:cNvSpPr/>
           <p:nvPr/>
         </p:nvSpPr>
         <p:spPr>
           <a:xfrm>
             <a:off x="8101440" y="2331720"/>
-            <a:ext cx="3501720" cy="1535760"/>
+            <a:ext cx="3501360" cy="1535400"/>
           </a:xfrm>
           <a:prstGeom prst="roundRect">
             <a:avLst>
@@ -3450,6 +3560,11 @@
             <a:noAutofit/>
           </a:bodyPr>
           <a:p>
+            <a:pPr>
+              <a:lnSpc>
+                <a:spcPct val="100000"/>
+              </a:lnSpc>
+            </a:pPr>
             <a:endParaRPr b="0" lang="en-US" sz="1800" spc="-1" strike="noStrike">
               <a:solidFill>
                 <a:srgbClr val="000000"/>
@@ -3461,14 +3576,14 @@
       </p:sp>
       <p:sp>
         <p:nvSpPr>
-          <p:cNvPr id="190" name="Shape 14"/>
+          <p:cNvPr id="194" name="Shape 14"/>
           <p:cNvSpPr/>
           <p:nvPr/>
         </p:nvSpPr>
         <p:spPr>
           <a:xfrm>
             <a:off x="8302680" y="2532960"/>
-            <a:ext cx="383760" cy="383760"/>
+            <a:ext cx="383400" cy="383400"/>
           </a:xfrm>
           <a:prstGeom prst="roundRect">
             <a:avLst>
@@ -3495,6 +3610,11 @@
             <a:noAutofit/>
           </a:bodyPr>
           <a:p>
+            <a:pPr>
+              <a:lnSpc>
+                <a:spcPct val="100000"/>
+              </a:lnSpc>
+            </a:pPr>
             <a:endParaRPr b="0" lang="en-US" sz="1800" spc="-1" strike="noStrike">
               <a:solidFill>
                 <a:srgbClr val="ffffff"/>
@@ -3506,14 +3626,14 @@
       </p:sp>
       <p:sp>
         <p:nvSpPr>
-          <p:cNvPr id="191" name="Shape 15"/>
+          <p:cNvPr id="195" name="Shape 15"/>
           <p:cNvSpPr/>
           <p:nvPr/>
         </p:nvSpPr>
         <p:spPr>
           <a:xfrm>
             <a:off x="8430840" y="2660760"/>
-            <a:ext cx="127800" cy="127800"/>
+            <a:ext cx="127440" cy="127440"/>
           </a:xfrm>
           <a:prstGeom prst="ellipse">
             <a:avLst/>
@@ -3536,6 +3656,11 @@
             <a:noAutofit/>
           </a:bodyPr>
           <a:p>
+            <a:pPr>
+              <a:lnSpc>
+                <a:spcPct val="100000"/>
+              </a:lnSpc>
+            </a:pPr>
             <a:endParaRPr b="0" lang="en-US" sz="1800" spc="-1" strike="noStrike">
               <a:solidFill>
                 <a:srgbClr val="ffffff"/>
@@ -3547,14 +3672,14 @@
       </p:sp>
       <p:sp>
         <p:nvSpPr>
-          <p:cNvPr id="192" name="Text 16"/>
+          <p:cNvPr id="196" name="Text 16"/>
           <p:cNvSpPr/>
           <p:nvPr/>
         </p:nvSpPr>
         <p:spPr>
           <a:xfrm>
             <a:off x="8302680" y="3008520"/>
-            <a:ext cx="3099600" cy="310680"/>
+            <a:ext cx="3099240" cy="310320"/>
           </a:xfrm>
           <a:prstGeom prst="rect">
             <a:avLst/>
@@ -3604,14 +3729,14 @@
       </p:sp>
       <p:sp>
         <p:nvSpPr>
-          <p:cNvPr id="193" name="Text 17"/>
+          <p:cNvPr id="197" name="Text 17"/>
           <p:cNvSpPr/>
           <p:nvPr/>
         </p:nvSpPr>
         <p:spPr>
           <a:xfrm>
             <a:off x="8302680" y="3300840"/>
-            <a:ext cx="3099600" cy="475200"/>
+            <a:ext cx="3099240" cy="474840"/>
           </a:xfrm>
           <a:prstGeom prst="rect">
             <a:avLst/>
@@ -3661,14 +3786,14 @@
       </p:sp>
       <p:sp>
         <p:nvSpPr>
-          <p:cNvPr id="194" name="Shape 18"/>
+          <p:cNvPr id="198" name="Shape 18"/>
           <p:cNvSpPr/>
           <p:nvPr/>
         </p:nvSpPr>
         <p:spPr>
           <a:xfrm>
             <a:off x="548640" y="4123800"/>
-            <a:ext cx="3501720" cy="1535760"/>
+            <a:ext cx="3501360" cy="1535400"/>
           </a:xfrm>
           <a:prstGeom prst="roundRect">
             <a:avLst>
@@ -3703,6 +3828,11 @@
             <a:noAutofit/>
           </a:bodyPr>
           <a:p>
+            <a:pPr>
+              <a:lnSpc>
+                <a:spcPct val="100000"/>
+              </a:lnSpc>
+            </a:pPr>
             <a:endParaRPr b="0" lang="en-US" sz="1800" spc="-1" strike="noStrike">
               <a:solidFill>
                 <a:srgbClr val="000000"/>
@@ -3714,14 +3844,14 @@
       </p:sp>
       <p:sp>
         <p:nvSpPr>
-          <p:cNvPr id="195" name="Shape 19"/>
+          <p:cNvPr id="199" name="Shape 19"/>
           <p:cNvSpPr/>
           <p:nvPr/>
         </p:nvSpPr>
         <p:spPr>
           <a:xfrm>
             <a:off x="749880" y="4325040"/>
-            <a:ext cx="383760" cy="383760"/>
+            <a:ext cx="383400" cy="383400"/>
           </a:xfrm>
           <a:prstGeom prst="roundRect">
             <a:avLst>
@@ -3748,6 +3878,11 @@
             <a:noAutofit/>
           </a:bodyPr>
           <a:p>
+            <a:pPr>
+              <a:lnSpc>
+                <a:spcPct val="100000"/>
+              </a:lnSpc>
+            </a:pPr>
             <a:endParaRPr b="0" lang="en-US" sz="1800" spc="-1" strike="noStrike">
               <a:solidFill>
                 <a:srgbClr val="000000"/>
@@ -3759,14 +3894,14 @@
       </p:sp>
       <p:sp>
         <p:nvSpPr>
-          <p:cNvPr id="196" name="Shape 20"/>
+          <p:cNvPr id="200" name="Shape 20"/>
           <p:cNvSpPr/>
           <p:nvPr/>
         </p:nvSpPr>
         <p:spPr>
           <a:xfrm>
             <a:off x="877680" y="4453200"/>
-            <a:ext cx="127800" cy="127800"/>
+            <a:ext cx="127440" cy="127440"/>
           </a:xfrm>
           <a:prstGeom prst="ellipse">
             <a:avLst/>
@@ -3789,6 +3924,11 @@
             <a:noAutofit/>
           </a:bodyPr>
           <a:p>
+            <a:pPr>
+              <a:lnSpc>
+                <a:spcPct val="100000"/>
+              </a:lnSpc>
+            </a:pPr>
             <a:endParaRPr b="0" lang="en-US" sz="1800" spc="-1" strike="noStrike">
               <a:solidFill>
                 <a:srgbClr val="000000"/>
@@ -3800,14 +3940,14 @@
       </p:sp>
       <p:sp>
         <p:nvSpPr>
-          <p:cNvPr id="197" name="Text 21"/>
+          <p:cNvPr id="201" name="Text 21"/>
           <p:cNvSpPr/>
           <p:nvPr/>
         </p:nvSpPr>
         <p:spPr>
           <a:xfrm>
             <a:off x="749880" y="4800600"/>
-            <a:ext cx="3099600" cy="310680"/>
+            <a:ext cx="3099240" cy="310320"/>
           </a:xfrm>
           <a:prstGeom prst="rect">
             <a:avLst/>
@@ -3857,14 +3997,14 @@
       </p:sp>
       <p:sp>
         <p:nvSpPr>
-          <p:cNvPr id="198" name="Text 22"/>
+          <p:cNvPr id="202" name="Text 22"/>
           <p:cNvSpPr/>
           <p:nvPr/>
         </p:nvSpPr>
         <p:spPr>
           <a:xfrm>
             <a:off x="749880" y="5093280"/>
-            <a:ext cx="3099600" cy="475200"/>
+            <a:ext cx="3099240" cy="474840"/>
           </a:xfrm>
           <a:prstGeom prst="rect">
             <a:avLst/>
@@ -3914,14 +4054,14 @@
       </p:sp>
       <p:sp>
         <p:nvSpPr>
-          <p:cNvPr id="199" name="Shape 23"/>
+          <p:cNvPr id="203" name="Shape 23"/>
           <p:cNvSpPr/>
           <p:nvPr/>
         </p:nvSpPr>
         <p:spPr>
           <a:xfrm>
             <a:off x="4325040" y="4123800"/>
-            <a:ext cx="3501720" cy="1535760"/>
+            <a:ext cx="3501360" cy="1535400"/>
           </a:xfrm>
           <a:prstGeom prst="roundRect">
             <a:avLst>
@@ -3956,6 +4096,11 @@
             <a:noAutofit/>
           </a:bodyPr>
           <a:p>
+            <a:pPr>
+              <a:lnSpc>
+                <a:spcPct val="100000"/>
+              </a:lnSpc>
+            </a:pPr>
             <a:endParaRPr b="0" lang="en-US" sz="1800" spc="-1" strike="noStrike">
               <a:solidFill>
                 <a:srgbClr val="000000"/>
@@ -3967,14 +4112,14 @@
       </p:sp>
       <p:sp>
         <p:nvSpPr>
-          <p:cNvPr id="200" name="Shape 24"/>
+          <p:cNvPr id="204" name="Shape 24"/>
           <p:cNvSpPr/>
           <p:nvPr/>
         </p:nvSpPr>
         <p:spPr>
           <a:xfrm>
             <a:off x="4526280" y="4325040"/>
-            <a:ext cx="383760" cy="383760"/>
+            <a:ext cx="383400" cy="383400"/>
           </a:xfrm>
           <a:prstGeom prst="roundRect">
             <a:avLst>
@@ -4001,6 +4146,11 @@
             <a:noAutofit/>
           </a:bodyPr>
           <a:p>
+            <a:pPr>
+              <a:lnSpc>
+                <a:spcPct val="100000"/>
+              </a:lnSpc>
+            </a:pPr>
             <a:endParaRPr b="0" lang="en-US" sz="1800" spc="-1" strike="noStrike">
               <a:solidFill>
                 <a:srgbClr val="ffffff"/>
@@ -4012,14 +4162,14 @@
       </p:sp>
       <p:sp>
         <p:nvSpPr>
-          <p:cNvPr id="201" name="Shape 25"/>
+          <p:cNvPr id="205" name="Shape 25"/>
           <p:cNvSpPr/>
           <p:nvPr/>
         </p:nvSpPr>
         <p:spPr>
           <a:xfrm>
             <a:off x="4654440" y="4453200"/>
-            <a:ext cx="127800" cy="127800"/>
+            <a:ext cx="127440" cy="127440"/>
           </a:xfrm>
           <a:prstGeom prst="ellipse">
             <a:avLst/>
@@ -4042,6 +4192,11 @@
             <a:noAutofit/>
           </a:bodyPr>
           <a:p>
+            <a:pPr>
+              <a:lnSpc>
+                <a:spcPct val="100000"/>
+              </a:lnSpc>
+            </a:pPr>
             <a:endParaRPr b="0" lang="en-US" sz="1800" spc="-1" strike="noStrike">
               <a:solidFill>
                 <a:srgbClr val="ffffff"/>
@@ -4053,14 +4208,14 @@
       </p:sp>
       <p:sp>
         <p:nvSpPr>
-          <p:cNvPr id="202" name="Text 26"/>
+          <p:cNvPr id="206" name="Text 26"/>
           <p:cNvSpPr/>
           <p:nvPr/>
         </p:nvSpPr>
         <p:spPr>
           <a:xfrm>
             <a:off x="4526280" y="4800600"/>
-            <a:ext cx="3099600" cy="310680"/>
+            <a:ext cx="3099240" cy="310320"/>
           </a:xfrm>
           <a:prstGeom prst="rect">
             <a:avLst/>
@@ -4110,14 +4265,14 @@
       </p:sp>
       <p:sp>
         <p:nvSpPr>
-          <p:cNvPr id="203" name="Text 27"/>
+          <p:cNvPr id="207" name="Text 27"/>
           <p:cNvSpPr/>
           <p:nvPr/>
         </p:nvSpPr>
         <p:spPr>
           <a:xfrm>
             <a:off x="4526280" y="5093280"/>
-            <a:ext cx="3099600" cy="475200"/>
+            <a:ext cx="3099240" cy="474840"/>
           </a:xfrm>
           <a:prstGeom prst="rect">
             <a:avLst/>
@@ -4167,14 +4322,14 @@
       </p:sp>
       <p:sp>
         <p:nvSpPr>
-          <p:cNvPr id="204" name="Shape 28"/>
+          <p:cNvPr id="208" name="Shape 28"/>
           <p:cNvSpPr/>
           <p:nvPr/>
         </p:nvSpPr>
         <p:spPr>
           <a:xfrm>
             <a:off x="8101440" y="4123800"/>
-            <a:ext cx="3501720" cy="1535760"/>
+            <a:ext cx="3501360" cy="1535400"/>
           </a:xfrm>
           <a:prstGeom prst="roundRect">
             <a:avLst>
@@ -4209,6 +4364,11 @@
             <a:noAutofit/>
           </a:bodyPr>
           <a:p>
+            <a:pPr>
+              <a:lnSpc>
+                <a:spcPct val="100000"/>
+              </a:lnSpc>
+            </a:pPr>
             <a:endParaRPr b="0" lang="en-US" sz="1800" spc="-1" strike="noStrike">
               <a:solidFill>
                 <a:srgbClr val="000000"/>
@@ -4220,14 +4380,14 @@
       </p:sp>
       <p:sp>
         <p:nvSpPr>
-          <p:cNvPr id="205" name="Shape 29"/>
+          <p:cNvPr id="209" name="Shape 29"/>
           <p:cNvSpPr/>
           <p:nvPr/>
         </p:nvSpPr>
         <p:spPr>
           <a:xfrm>
             <a:off x="8302680" y="4325040"/>
-            <a:ext cx="383760" cy="383760"/>
+            <a:ext cx="383400" cy="383400"/>
           </a:xfrm>
           <a:prstGeom prst="roundRect">
             <a:avLst>
@@ -4254,6 +4414,11 @@
             <a:noAutofit/>
           </a:bodyPr>
           <a:p>
+            <a:pPr>
+              <a:lnSpc>
+                <a:spcPct val="100000"/>
+              </a:lnSpc>
+            </a:pPr>
             <a:endParaRPr b="0" lang="en-US" sz="1800" spc="-1" strike="noStrike">
               <a:solidFill>
                 <a:srgbClr val="ffffff"/>
@@ -4265,14 +4430,14 @@
       </p:sp>
       <p:sp>
         <p:nvSpPr>
-          <p:cNvPr id="206" name="Shape 30"/>
+          <p:cNvPr id="210" name="Shape 30"/>
           <p:cNvSpPr/>
           <p:nvPr/>
         </p:nvSpPr>
         <p:spPr>
           <a:xfrm>
             <a:off x="8430840" y="4453200"/>
-            <a:ext cx="127800" cy="127800"/>
+            <a:ext cx="127440" cy="127440"/>
           </a:xfrm>
           <a:prstGeom prst="ellipse">
             <a:avLst/>
@@ -4295,6 +4460,11 @@
             <a:noAutofit/>
           </a:bodyPr>
           <a:p>
+            <a:pPr>
+              <a:lnSpc>
+                <a:spcPct val="100000"/>
+              </a:lnSpc>
+            </a:pPr>
             <a:endParaRPr b="0" lang="en-US" sz="1800" spc="-1" strike="noStrike">
               <a:solidFill>
                 <a:srgbClr val="ffffff"/>
@@ -4306,14 +4476,14 @@
       </p:sp>
       <p:sp>
         <p:nvSpPr>
-          <p:cNvPr id="207" name="Text 31"/>
+          <p:cNvPr id="211" name="Text 31"/>
           <p:cNvSpPr/>
           <p:nvPr/>
         </p:nvSpPr>
         <p:spPr>
           <a:xfrm>
             <a:off x="8302680" y="4800600"/>
-            <a:ext cx="3099600" cy="310680"/>
+            <a:ext cx="3099240" cy="310320"/>
           </a:xfrm>
           <a:prstGeom prst="rect">
             <a:avLst/>
@@ -4363,14 +4533,14 @@
       </p:sp>
       <p:sp>
         <p:nvSpPr>
-          <p:cNvPr id="208" name="Text 32"/>
+          <p:cNvPr id="212" name="Text 32"/>
           <p:cNvSpPr/>
           <p:nvPr/>
         </p:nvSpPr>
         <p:spPr>
           <a:xfrm>
             <a:off x="8302680" y="5093280"/>
-            <a:ext cx="3099600" cy="475200"/>
+            <a:ext cx="3099240" cy="474840"/>
           </a:xfrm>
           <a:prstGeom prst="rect">
             <a:avLst/>
@@ -4420,14 +4590,14 @@
       </p:sp>
       <p:sp>
         <p:nvSpPr>
-          <p:cNvPr id="209" name="Text 33"/>
+          <p:cNvPr id="213" name="Text 33"/>
           <p:cNvSpPr/>
           <p:nvPr/>
         </p:nvSpPr>
         <p:spPr>
           <a:xfrm>
             <a:off x="11567160" y="6492240"/>
-            <a:ext cx="456840" cy="273960"/>
+            <a:ext cx="456480" cy="273600"/>
           </a:xfrm>
           <a:prstGeom prst="rect">
             <a:avLst/>
@@ -4521,7 +4691,7 @@
         <p:spPr>
           <a:xfrm>
             <a:off x="548640" y="384120"/>
-            <a:ext cx="7314840" cy="319680"/>
+            <a:ext cx="7314480" cy="319320"/>
           </a:xfrm>
           <a:prstGeom prst="rect">
             <a:avLst/>
@@ -4551,7 +4721,7 @@
               </a:tabLst>
             </a:pPr>
             <a:r>
-              <a:rPr b="1" lang="en-US" sz="1300" spc="199" strike="noStrike">
+              <a:rPr b="1" lang="en-US" sz="1300" spc="197" strike="noStrike">
                 <a:solidFill>
                   <a:srgbClr val="028090"/>
                 </a:solidFill>
@@ -4578,7 +4748,7 @@
         <p:spPr>
           <a:xfrm>
             <a:off x="548640" y="658440"/>
-            <a:ext cx="11063880" cy="822600"/>
+            <a:ext cx="11063520" cy="822240"/>
           </a:xfrm>
           <a:prstGeom prst="rect">
             <a:avLst/>
@@ -4635,7 +4805,7 @@
         <p:spPr>
           <a:xfrm>
             <a:off x="548640" y="1508760"/>
-            <a:ext cx="10881000" cy="822600"/>
+            <a:ext cx="10880640" cy="822240"/>
           </a:xfrm>
           <a:prstGeom prst="rect">
             <a:avLst/>
@@ -4692,7 +4862,7 @@
         <p:spPr>
           <a:xfrm>
             <a:off x="548640" y="2606040"/>
-            <a:ext cx="3501720" cy="2788560"/>
+            <a:ext cx="3501360" cy="2788200"/>
           </a:xfrm>
           <a:prstGeom prst="roundRect">
             <a:avLst>
@@ -4727,6 +4897,11 @@
             <a:noAutofit/>
           </a:bodyPr>
           <a:p>
+            <a:pPr>
+              <a:lnSpc>
+                <a:spcPct val="100000"/>
+              </a:lnSpc>
+            </a:pPr>
             <a:endParaRPr b="0" lang="en-US" sz="1800" spc="-1" strike="noStrike">
               <a:solidFill>
                 <a:srgbClr val="000000"/>
@@ -4745,7 +4920,7 @@
         <p:spPr>
           <a:xfrm>
             <a:off x="804600" y="2862000"/>
-            <a:ext cx="502560" cy="502560"/>
+            <a:ext cx="502200" cy="502200"/>
           </a:xfrm>
           <a:prstGeom prst="ellipse">
             <a:avLst/>
@@ -4770,6 +4945,11 @@
             <a:noAutofit/>
           </a:bodyPr>
           <a:p>
+            <a:pPr>
+              <a:lnSpc>
+                <a:spcPct val="100000"/>
+              </a:lnSpc>
+            </a:pPr>
             <a:endParaRPr b="0" lang="en-US" sz="1800" spc="-1" strike="noStrike">
               <a:solidFill>
                 <a:srgbClr val="ffffff"/>
@@ -4788,7 +4968,7 @@
         <p:spPr>
           <a:xfrm>
             <a:off x="804600" y="2862000"/>
-            <a:ext cx="502560" cy="502560"/>
+            <a:ext cx="502200" cy="502200"/>
           </a:xfrm>
           <a:prstGeom prst="rect">
             <a:avLst/>
@@ -4845,7 +5025,7 @@
         <p:spPr>
           <a:xfrm>
             <a:off x="822960" y="3520440"/>
-            <a:ext cx="2953080" cy="365400"/>
+            <a:ext cx="2952720" cy="365040"/>
           </a:xfrm>
           <a:prstGeom prst="rect">
             <a:avLst/>
@@ -4902,7 +5082,7 @@
         <p:spPr>
           <a:xfrm>
             <a:off x="822960" y="3904560"/>
-            <a:ext cx="2953080" cy="1325520"/>
+            <a:ext cx="2952720" cy="1325160"/>
           </a:xfrm>
           <a:prstGeom prst="rect">
             <a:avLst/>
@@ -4959,7 +5139,7 @@
         <p:spPr>
           <a:xfrm>
             <a:off x="4325040" y="2606040"/>
-            <a:ext cx="3501720" cy="2788560"/>
+            <a:ext cx="3501360" cy="2788200"/>
           </a:xfrm>
           <a:prstGeom prst="roundRect">
             <a:avLst>
@@ -4994,6 +5174,11 @@
             <a:noAutofit/>
           </a:bodyPr>
           <a:p>
+            <a:pPr>
+              <a:lnSpc>
+                <a:spcPct val="100000"/>
+              </a:lnSpc>
+            </a:pPr>
             <a:endParaRPr b="0" lang="en-US" sz="1800" spc="-1" strike="noStrike">
               <a:solidFill>
                 <a:srgbClr val="000000"/>
@@ -5012,7 +5197,7 @@
         <p:spPr>
           <a:xfrm>
             <a:off x="4581000" y="2862000"/>
-            <a:ext cx="502560" cy="502560"/>
+            <a:ext cx="502200" cy="502200"/>
           </a:xfrm>
           <a:prstGeom prst="ellipse">
             <a:avLst/>
@@ -5037,6 +5222,11 @@
             <a:noAutofit/>
           </a:bodyPr>
           <a:p>
+            <a:pPr>
+              <a:lnSpc>
+                <a:spcPct val="100000"/>
+              </a:lnSpc>
+            </a:pPr>
             <a:endParaRPr b="0" lang="en-US" sz="1800" spc="-1" strike="noStrike">
               <a:solidFill>
                 <a:srgbClr val="ffffff"/>
@@ -5055,7 +5245,7 @@
         <p:spPr>
           <a:xfrm>
             <a:off x="4581000" y="2862000"/>
-            <a:ext cx="502560" cy="502560"/>
+            <a:ext cx="502200" cy="502200"/>
           </a:xfrm>
           <a:prstGeom prst="rect">
             <a:avLst/>
@@ -5112,7 +5302,7 @@
         <p:spPr>
           <a:xfrm>
             <a:off x="4599360" y="3520440"/>
-            <a:ext cx="2953080" cy="365400"/>
+            <a:ext cx="2952720" cy="365040"/>
           </a:xfrm>
           <a:prstGeom prst="rect">
             <a:avLst/>
@@ -5169,7 +5359,7 @@
         <p:spPr>
           <a:xfrm>
             <a:off x="4599360" y="3904560"/>
-            <a:ext cx="2953080" cy="1325520"/>
+            <a:ext cx="2952720" cy="1325160"/>
           </a:xfrm>
           <a:prstGeom prst="rect">
             <a:avLst/>
@@ -5226,7 +5416,7 @@
         <p:spPr>
           <a:xfrm>
             <a:off x="8101440" y="2606040"/>
-            <a:ext cx="3501720" cy="2788560"/>
+            <a:ext cx="3501360" cy="2788200"/>
           </a:xfrm>
           <a:prstGeom prst="roundRect">
             <a:avLst>
@@ -5261,6 +5451,11 @@
             <a:noAutofit/>
           </a:bodyPr>
           <a:p>
+            <a:pPr>
+              <a:lnSpc>
+                <a:spcPct val="100000"/>
+              </a:lnSpc>
+            </a:pPr>
             <a:endParaRPr b="0" lang="en-US" sz="1800" spc="-1" strike="noStrike">
               <a:solidFill>
                 <a:srgbClr val="000000"/>
@@ -5279,7 +5474,7 @@
         <p:spPr>
           <a:xfrm>
             <a:off x="8357760" y="2862000"/>
-            <a:ext cx="502560" cy="502560"/>
+            <a:ext cx="502200" cy="502200"/>
           </a:xfrm>
           <a:prstGeom prst="ellipse">
             <a:avLst/>
@@ -5304,6 +5499,11 @@
             <a:noAutofit/>
           </a:bodyPr>
           <a:p>
+            <a:pPr>
+              <a:lnSpc>
+                <a:spcPct val="100000"/>
+              </a:lnSpc>
+            </a:pPr>
             <a:endParaRPr b="0" lang="en-US" sz="1800" spc="-1" strike="noStrike">
               <a:solidFill>
                 <a:srgbClr val="ffffff"/>
@@ -5322,7 +5522,7 @@
         <p:spPr>
           <a:xfrm>
             <a:off x="8357760" y="2862000"/>
-            <a:ext cx="502560" cy="502560"/>
+            <a:ext cx="502200" cy="502200"/>
           </a:xfrm>
           <a:prstGeom prst="rect">
             <a:avLst/>
@@ -5379,7 +5579,7 @@
         <p:spPr>
           <a:xfrm>
             <a:off x="8375760" y="3520440"/>
-            <a:ext cx="2953080" cy="365400"/>
+            <a:ext cx="2952720" cy="365040"/>
           </a:xfrm>
           <a:prstGeom prst="rect">
             <a:avLst/>
@@ -5436,7 +5636,7 @@
         <p:spPr>
           <a:xfrm>
             <a:off x="8375760" y="3904560"/>
-            <a:ext cx="2953080" cy="1325520"/>
+            <a:ext cx="2952720" cy="1325160"/>
           </a:xfrm>
           <a:prstGeom prst="rect">
             <a:avLst/>
@@ -5493,7 +5693,7 @@
         <p:spPr>
           <a:xfrm>
             <a:off x="548640" y="5623560"/>
-            <a:ext cx="10881000" cy="712800"/>
+            <a:ext cx="10880640" cy="712440"/>
           </a:xfrm>
           <a:prstGeom prst="roundRect">
             <a:avLst>
@@ -5518,6 +5718,11 @@
             <a:noAutofit/>
           </a:bodyPr>
           <a:p>
+            <a:pPr>
+              <a:lnSpc>
+                <a:spcPct val="100000"/>
+              </a:lnSpc>
+            </a:pPr>
             <a:endParaRPr b="0" lang="en-US" sz="1800" spc="-1" strike="noStrike">
               <a:solidFill>
                 <a:srgbClr val="ffffff"/>
@@ -5536,7 +5741,7 @@
         <p:spPr>
           <a:xfrm>
             <a:off x="822960" y="5623560"/>
-            <a:ext cx="10332360" cy="712800"/>
+            <a:ext cx="10332000" cy="712440"/>
           </a:xfrm>
           <a:prstGeom prst="rect">
             <a:avLst/>
@@ -5603,7 +5808,7 @@
         <p:spPr>
           <a:xfrm>
             <a:off x="11567160" y="6492240"/>
-            <a:ext cx="456840" cy="273960"/>
+            <a:ext cx="456480" cy="273600"/>
           </a:xfrm>
           <a:prstGeom prst="rect">
             <a:avLst/>
@@ -5697,7 +5902,7 @@
         <p:spPr>
           <a:xfrm>
             <a:off x="548640" y="384120"/>
-            <a:ext cx="7314840" cy="319680"/>
+            <a:ext cx="7314480" cy="319320"/>
           </a:xfrm>
           <a:prstGeom prst="rect">
             <a:avLst/>
@@ -5727,7 +5932,7 @@
               </a:tabLst>
             </a:pPr>
             <a:r>
-              <a:rPr b="1" lang="en-US" sz="1300" spc="199" strike="noStrike">
+              <a:rPr b="1" lang="en-US" sz="1300" spc="197" strike="noStrike">
                 <a:solidFill>
                   <a:srgbClr val="028090"/>
                 </a:solidFill>
@@ -5754,7 +5959,7 @@
         <p:spPr>
           <a:xfrm>
             <a:off x="548640" y="658440"/>
-            <a:ext cx="11063880" cy="822600"/>
+            <a:ext cx="11063520" cy="822240"/>
           </a:xfrm>
           <a:prstGeom prst="rect">
             <a:avLst/>
@@ -5811,7 +6016,7 @@
         <p:spPr>
           <a:xfrm>
             <a:off x="548640" y="1417320"/>
-            <a:ext cx="10881000" cy="548280"/>
+            <a:ext cx="10880640" cy="547920"/>
           </a:xfrm>
           <a:prstGeom prst="rect">
             <a:avLst/>
@@ -5868,7 +6073,7 @@
         <p:spPr>
           <a:xfrm>
             <a:off x="548640" y="5831640"/>
-            <a:ext cx="10881000" cy="365400"/>
+            <a:ext cx="10880640" cy="365040"/>
           </a:xfrm>
           <a:prstGeom prst="rect">
             <a:avLst/>
@@ -5925,7 +6130,7 @@
         <p:spPr>
           <a:xfrm>
             <a:off x="11567160" y="6492240"/>
-            <a:ext cx="456840" cy="273960"/>
+            <a:ext cx="456480" cy="273600"/>
           </a:xfrm>
           <a:prstGeom prst="rect">
             <a:avLst/>
@@ -5986,7 +6191,7 @@
         <p:spPr>
           <a:xfrm>
             <a:off x="770400" y="2322000"/>
-            <a:ext cx="10905120" cy="3431160"/>
+            <a:ext cx="10904760" cy="3430800"/>
           </a:xfrm>
           <a:prstGeom prst="rect">
             <a:avLst/>
@@ -6042,7 +6247,7 @@
         <p:spPr>
           <a:xfrm>
             <a:off x="548640" y="384120"/>
-            <a:ext cx="7314840" cy="319680"/>
+            <a:ext cx="7314480" cy="319320"/>
           </a:xfrm>
           <a:prstGeom prst="rect">
             <a:avLst/>
@@ -6072,7 +6277,7 @@
               </a:tabLst>
             </a:pPr>
             <a:r>
-              <a:rPr b="1" lang="en-US" sz="1300" spc="199" strike="noStrike">
+              <a:rPr b="1" lang="en-US" sz="1300" spc="197" strike="noStrike">
                 <a:solidFill>
                   <a:srgbClr val="028090"/>
                 </a:solidFill>
@@ -6099,7 +6304,7 @@
         <p:spPr>
           <a:xfrm>
             <a:off x="548640" y="658440"/>
-            <a:ext cx="11063880" cy="822600"/>
+            <a:ext cx="11063520" cy="822240"/>
           </a:xfrm>
           <a:prstGeom prst="rect">
             <a:avLst/>
@@ -6136,77 +6341,7 @@
                 <a:latin typeface="Cambria"/>
                 <a:ea typeface="Cambria"/>
               </a:rPr>
-              <a:t>The </a:t>
-            </a:r>
-            <a:r>
-              <a:rPr b="1" lang="en-US" sz="3200" spc="-1" strike="noStrike">
-                <a:solidFill>
-                  <a:srgbClr val="0b2540"/>
-                </a:solidFill>
-                <a:latin typeface="Cambria"/>
-                <a:ea typeface="Cambria"/>
-              </a:rPr>
-              <a:t>dashboa</a:t>
-            </a:r>
-            <a:r>
-              <a:rPr b="1" lang="en-US" sz="3200" spc="-1" strike="noStrike">
-                <a:solidFill>
-                  <a:srgbClr val="0b2540"/>
-                </a:solidFill>
-                <a:latin typeface="Cambria"/>
-                <a:ea typeface="Cambria"/>
-              </a:rPr>
-              <a:t>rd, live </a:t>
-            </a:r>
-            <a:r>
-              <a:rPr b="1" lang="en-US" sz="3200" spc="-1" strike="noStrike">
-                <a:solidFill>
-                  <a:srgbClr val="0b2540"/>
-                </a:solidFill>
-                <a:latin typeface="Cambria"/>
-                <a:ea typeface="Cambria"/>
-              </a:rPr>
-              <a:t>inside </a:t>
-            </a:r>
-            <a:r>
-              <a:rPr b="1" lang="en-US" sz="3200" spc="-1" strike="noStrike">
-                <a:solidFill>
-                  <a:srgbClr val="0b2540"/>
-                </a:solidFill>
-                <a:latin typeface="Cambria"/>
-                <a:ea typeface="Cambria"/>
-              </a:rPr>
-              <a:t>Jupyter</a:t>
-            </a:r>
-            <a:r>
-              <a:rPr b="1" lang="en-US" sz="3200" spc="-1" strike="noStrike">
-                <a:solidFill>
-                  <a:srgbClr val="0b2540"/>
-                </a:solidFill>
-                <a:latin typeface="Cambria"/>
-                <a:ea typeface="Cambria"/>
-              </a:rPr>
-              <a:t>Lab</a:t>
-            </a:r>
-            <a:r>
-              <a:rPr b="1" lang="en-US" sz="3200" spc="-1" strike="noStrike">
-                <a:solidFill>
-                  <a:srgbClr val="0b2540"/>
-                </a:solidFill>
-                <a:latin typeface="Cambria"/>
-                <a:ea typeface="Cambria"/>
-              </a:rPr>
-              <a:t> </a:t>
-            </a:r>
-            <a:r>
-              <a:rPr b="1" lang="en-US" sz="3200" spc="-1" strike="noStrike">
-                <a:solidFill>
-                  <a:srgbClr val="0b2540"/>
-                </a:solidFill>
-                <a:latin typeface="Cambria"/>
-                <a:ea typeface="Cambria"/>
-              </a:rPr>
-              <a:t>(1/2)</a:t>
+              <a:t>The dashboard, live inside JupyterLab (1/2)</a:t>
             </a:r>
             <a:endParaRPr b="0" lang="en-US" sz="3200" spc="-1" strike="noStrike">
               <a:solidFill>
@@ -6226,7 +6361,7 @@
         <p:spPr>
           <a:xfrm>
             <a:off x="548640" y="1463040"/>
-            <a:ext cx="10881000" cy="456840"/>
+            <a:ext cx="10880640" cy="456480"/>
           </a:xfrm>
           <a:prstGeom prst="rect">
             <a:avLst/>
@@ -6283,7 +6418,7 @@
         <p:spPr>
           <a:xfrm>
             <a:off x="548640" y="2084760"/>
-            <a:ext cx="3513960" cy="1599840"/>
+            <a:ext cx="3513600" cy="1599480"/>
           </a:xfrm>
           <a:prstGeom prst="roundRect">
             <a:avLst>
@@ -6318,6 +6453,11 @@
             <a:noAutofit/>
           </a:bodyPr>
           <a:p>
+            <a:pPr>
+              <a:lnSpc>
+                <a:spcPct val="100000"/>
+              </a:lnSpc>
+            </a:pPr>
             <a:endParaRPr b="0" lang="en-US" sz="1800" spc="-1" strike="noStrike">
               <a:solidFill>
                 <a:srgbClr val="000000"/>
@@ -6340,7 +6480,7 @@
         <p:spPr>
           <a:xfrm>
             <a:off x="685800" y="2504880"/>
-            <a:ext cx="3239640" cy="759960"/>
+            <a:ext cx="3239280" cy="759600"/>
           </a:xfrm>
           <a:prstGeom prst="rect">
             <a:avLst/>
@@ -6359,7 +6499,7 @@
         <p:spPr>
           <a:xfrm>
             <a:off x="548640" y="3721680"/>
-            <a:ext cx="3513960" cy="200880"/>
+            <a:ext cx="3513600" cy="200520"/>
           </a:xfrm>
           <a:prstGeom prst="rect">
             <a:avLst/>
@@ -6416,7 +6556,7 @@
         <p:spPr>
           <a:xfrm>
             <a:off x="548640" y="3922920"/>
-            <a:ext cx="3513960" cy="246600"/>
+            <a:ext cx="3513600" cy="246240"/>
           </a:xfrm>
           <a:prstGeom prst="rect">
             <a:avLst/>
@@ -6473,7 +6613,7 @@
         <p:spPr>
           <a:xfrm>
             <a:off x="4337280" y="2084760"/>
-            <a:ext cx="3513960" cy="1599840"/>
+            <a:ext cx="3513600" cy="1599480"/>
           </a:xfrm>
           <a:prstGeom prst="roundRect">
             <a:avLst>
@@ -6508,6 +6648,11 @@
             <a:noAutofit/>
           </a:bodyPr>
           <a:p>
+            <a:pPr>
+              <a:lnSpc>
+                <a:spcPct val="100000"/>
+              </a:lnSpc>
+            </a:pPr>
             <a:endParaRPr b="0" lang="en-US" sz="1800" spc="-1" strike="noStrike">
               <a:solidFill>
                 <a:srgbClr val="000000"/>
@@ -6530,7 +6675,7 @@
         <p:spPr>
           <a:xfrm>
             <a:off x="4474440" y="2467440"/>
-            <a:ext cx="3239640" cy="834480"/>
+            <a:ext cx="3239280" cy="834120"/>
           </a:xfrm>
           <a:prstGeom prst="rect">
             <a:avLst/>
@@ -6549,7 +6694,7 @@
         <p:spPr>
           <a:xfrm>
             <a:off x="4337280" y="3721680"/>
-            <a:ext cx="3513960" cy="200880"/>
+            <a:ext cx="3513600" cy="200520"/>
           </a:xfrm>
           <a:prstGeom prst="rect">
             <a:avLst/>
@@ -6606,7 +6751,7 @@
         <p:spPr>
           <a:xfrm>
             <a:off x="4337280" y="3922920"/>
-            <a:ext cx="3513960" cy="246600"/>
+            <a:ext cx="3513600" cy="246240"/>
           </a:xfrm>
           <a:prstGeom prst="rect">
             <a:avLst/>
@@ -6663,7 +6808,7 @@
         <p:spPr>
           <a:xfrm>
             <a:off x="8125920" y="2084760"/>
-            <a:ext cx="3513960" cy="1599840"/>
+            <a:ext cx="3513600" cy="1599480"/>
           </a:xfrm>
           <a:prstGeom prst="roundRect">
             <a:avLst>
@@ -6698,6 +6843,11 @@
             <a:noAutofit/>
           </a:bodyPr>
           <a:p>
+            <a:pPr>
+              <a:lnSpc>
+                <a:spcPct val="100000"/>
+              </a:lnSpc>
+            </a:pPr>
             <a:endParaRPr b="0" lang="en-US" sz="1800" spc="-1" strike="noStrike">
               <a:solidFill>
                 <a:srgbClr val="000000"/>
@@ -6720,7 +6870,7 @@
         <p:spPr>
           <a:xfrm>
             <a:off x="8263080" y="2467440"/>
-            <a:ext cx="3239640" cy="834480"/>
+            <a:ext cx="3239280" cy="834120"/>
           </a:xfrm>
           <a:prstGeom prst="rect">
             <a:avLst/>
@@ -6739,7 +6889,7 @@
         <p:spPr>
           <a:xfrm>
             <a:off x="8125920" y="3721680"/>
-            <a:ext cx="3513960" cy="200880"/>
+            <a:ext cx="3513600" cy="200520"/>
           </a:xfrm>
           <a:prstGeom prst="rect">
             <a:avLst/>
@@ -6796,7 +6946,7 @@
         <p:spPr>
           <a:xfrm>
             <a:off x="8125920" y="3922920"/>
-            <a:ext cx="3513960" cy="246600"/>
+            <a:ext cx="3513600" cy="246240"/>
           </a:xfrm>
           <a:prstGeom prst="rect">
             <a:avLst/>
@@ -6853,7 +7003,7 @@
         <p:spPr>
           <a:xfrm>
             <a:off x="548640" y="4370760"/>
-            <a:ext cx="3513960" cy="1599840"/>
+            <a:ext cx="3513600" cy="1599480"/>
           </a:xfrm>
           <a:prstGeom prst="roundRect">
             <a:avLst>
@@ -6888,6 +7038,11 @@
             <a:noAutofit/>
           </a:bodyPr>
           <a:p>
+            <a:pPr>
+              <a:lnSpc>
+                <a:spcPct val="100000"/>
+              </a:lnSpc>
+            </a:pPr>
             <a:endParaRPr b="0" lang="en-US" sz="1800" spc="-1" strike="noStrike">
               <a:solidFill>
                 <a:srgbClr val="000000"/>
@@ -6910,7 +7065,7 @@
         <p:spPr>
           <a:xfrm>
             <a:off x="685800" y="4597920"/>
-            <a:ext cx="3239640" cy="1145520"/>
+            <a:ext cx="3239280" cy="1145160"/>
           </a:xfrm>
           <a:prstGeom prst="rect">
             <a:avLst/>
@@ -6929,7 +7084,7 @@
         <p:spPr>
           <a:xfrm>
             <a:off x="548640" y="6007680"/>
-            <a:ext cx="3513960" cy="200880"/>
+            <a:ext cx="3513600" cy="200520"/>
           </a:xfrm>
           <a:prstGeom prst="rect">
             <a:avLst/>
@@ -6986,7 +7141,7 @@
         <p:spPr>
           <a:xfrm>
             <a:off x="548640" y="6208920"/>
-            <a:ext cx="3513960" cy="246600"/>
+            <a:ext cx="3513600" cy="246240"/>
           </a:xfrm>
           <a:prstGeom prst="rect">
             <a:avLst/>
@@ -7043,7 +7198,7 @@
         <p:spPr>
           <a:xfrm>
             <a:off x="4337280" y="4370760"/>
-            <a:ext cx="3513960" cy="1599840"/>
+            <a:ext cx="3513600" cy="1599480"/>
           </a:xfrm>
           <a:prstGeom prst="roundRect">
             <a:avLst>
@@ -7078,6 +7233,11 @@
             <a:noAutofit/>
           </a:bodyPr>
           <a:p>
+            <a:pPr>
+              <a:lnSpc>
+                <a:spcPct val="100000"/>
+              </a:lnSpc>
+            </a:pPr>
             <a:endParaRPr b="0" lang="en-US" sz="1800" spc="-1" strike="noStrike">
               <a:solidFill>
                 <a:srgbClr val="000000"/>
@@ -7100,7 +7260,7 @@
         <p:spPr>
           <a:xfrm>
             <a:off x="5269320" y="4507920"/>
-            <a:ext cx="1649520" cy="1325520"/>
+            <a:ext cx="1649160" cy="1325160"/>
           </a:xfrm>
           <a:prstGeom prst="rect">
             <a:avLst/>
@@ -7119,7 +7279,7 @@
         <p:spPr>
           <a:xfrm>
             <a:off x="4337280" y="6007680"/>
-            <a:ext cx="3513960" cy="200880"/>
+            <a:ext cx="3513600" cy="200520"/>
           </a:xfrm>
           <a:prstGeom prst="rect">
             <a:avLst/>
@@ -7176,7 +7336,7 @@
         <p:spPr>
           <a:xfrm>
             <a:off x="4337280" y="6208920"/>
-            <a:ext cx="3513960" cy="246600"/>
+            <a:ext cx="3513600" cy="246240"/>
           </a:xfrm>
           <a:prstGeom prst="rect">
             <a:avLst/>
@@ -7233,7 +7393,7 @@
         <p:spPr>
           <a:xfrm>
             <a:off x="8125920" y="4370760"/>
-            <a:ext cx="3513960" cy="1599840"/>
+            <a:ext cx="3513600" cy="1599480"/>
           </a:xfrm>
           <a:prstGeom prst="roundRect">
             <a:avLst>
@@ -7268,6 +7428,11 @@
             <a:noAutofit/>
           </a:bodyPr>
           <a:p>
+            <a:pPr>
+              <a:lnSpc>
+                <a:spcPct val="100000"/>
+              </a:lnSpc>
+            </a:pPr>
             <a:endParaRPr b="0" lang="en-US" sz="1800" spc="-1" strike="noStrike">
               <a:solidFill>
                 <a:srgbClr val="000000"/>
@@ -7290,7 +7455,7 @@
         <p:spPr>
           <a:xfrm>
             <a:off x="9058320" y="4507920"/>
-            <a:ext cx="1649520" cy="1325520"/>
+            <a:ext cx="1649160" cy="1325160"/>
           </a:xfrm>
           <a:prstGeom prst="rect">
             <a:avLst/>
@@ -7309,7 +7474,7 @@
         <p:spPr>
           <a:xfrm>
             <a:off x="8125920" y="6007680"/>
-            <a:ext cx="3513960" cy="200880"/>
+            <a:ext cx="3513600" cy="200520"/>
           </a:xfrm>
           <a:prstGeom prst="rect">
             <a:avLst/>
@@ -7366,7 +7531,7 @@
         <p:spPr>
           <a:xfrm>
             <a:off x="8125920" y="6208920"/>
-            <a:ext cx="3513960" cy="246600"/>
+            <a:ext cx="3513600" cy="246240"/>
           </a:xfrm>
           <a:prstGeom prst="rect">
             <a:avLst/>
@@ -7423,7 +7588,7 @@
         <p:spPr>
           <a:xfrm>
             <a:off x="11567160" y="6492240"/>
-            <a:ext cx="456840" cy="273960"/>
+            <a:ext cx="456480" cy="273600"/>
           </a:xfrm>
           <a:prstGeom prst="rect">
             <a:avLst/>
@@ -7517,7 +7682,7 @@
         <p:spPr>
           <a:xfrm>
             <a:off x="548640" y="384120"/>
-            <a:ext cx="7314840" cy="319680"/>
+            <a:ext cx="7314480" cy="319320"/>
           </a:xfrm>
           <a:prstGeom prst="rect">
             <a:avLst/>
@@ -7547,7 +7712,7 @@
               </a:tabLst>
             </a:pPr>
             <a:r>
-              <a:rPr b="1" lang="en-US" sz="1300" spc="199" strike="noStrike">
+              <a:rPr b="1" lang="en-US" sz="1300" spc="197" strike="noStrike">
                 <a:solidFill>
                   <a:srgbClr val="028090"/>
                 </a:solidFill>
@@ -7574,7 +7739,7 @@
         <p:spPr>
           <a:xfrm>
             <a:off x="548640" y="658440"/>
-            <a:ext cx="11063880" cy="822600"/>
+            <a:ext cx="11063520" cy="822240"/>
           </a:xfrm>
           <a:prstGeom prst="rect">
             <a:avLst/>
@@ -7611,37 +7776,7 @@
                 <a:latin typeface="Cambria"/>
                 <a:ea typeface="Cambria"/>
               </a:rPr>
-              <a:t>The dashboard, </a:t>
-            </a:r>
-            <a:r>
-              <a:rPr b="1" lang="en-US" sz="3200" spc="-1" strike="noStrike">
-                <a:solidFill>
-                  <a:srgbClr val="0b2540"/>
-                </a:solidFill>
-                <a:latin typeface="Cambria"/>
-                <a:ea typeface="Cambria"/>
-              </a:rPr>
-              <a:t>live inside </a:t>
-            </a:r>
-            <a:r>
-              <a:rPr b="1" lang="en-US" sz="3200" spc="-1" strike="noStrike">
-                <a:solidFill>
-                  <a:srgbClr val="0b2540"/>
-                </a:solidFill>
-                <a:latin typeface="Cambria"/>
-                <a:ea typeface="Cambria"/>
-              </a:rPr>
-              <a:t>JupyterLab</a:t>
-            </a:r>
-            <a:r>
-              <a:rPr b="1" lang="en-US" sz="3200" spc="-1" strike="noStrike">
-                <a:solidFill>
-                  <a:srgbClr val="0b2540"/>
-                </a:solidFill>
-                <a:latin typeface="Cambria"/>
-                <a:ea typeface="Cambria"/>
-              </a:rPr>
-              <a:t> (2/2)</a:t>
+              <a:t>The dashboard, live inside JupyterLab (2/2)</a:t>
             </a:r>
             <a:endParaRPr b="0" lang="en-US" sz="3200" spc="-1" strike="noStrike">
               <a:solidFill>
@@ -7661,7 +7796,7 @@
         <p:spPr>
           <a:xfrm>
             <a:off x="548640" y="1965960"/>
-            <a:ext cx="3483360" cy="3428640"/>
+            <a:ext cx="3483000" cy="3428280"/>
           </a:xfrm>
           <a:prstGeom prst="roundRect">
             <a:avLst>
@@ -7696,6 +7831,11 @@
             <a:noAutofit/>
           </a:bodyPr>
           <a:p>
+            <a:pPr>
+              <a:lnSpc>
+                <a:spcPct val="100000"/>
+              </a:lnSpc>
+            </a:pPr>
             <a:endParaRPr b="0" lang="en-US" sz="1800" spc="-1" strike="noStrike">
               <a:solidFill>
                 <a:srgbClr val="000000"/>
@@ -7718,7 +7858,7 @@
         <p:spPr>
           <a:xfrm>
             <a:off x="777240" y="2464560"/>
-            <a:ext cx="3026160" cy="2431800"/>
+            <a:ext cx="3025800" cy="2431440"/>
           </a:xfrm>
           <a:prstGeom prst="rect">
             <a:avLst/>
@@ -7737,7 +7877,7 @@
         <p:spPr>
           <a:xfrm>
             <a:off x="548640" y="5504760"/>
-            <a:ext cx="3483360" cy="273960"/>
+            <a:ext cx="3483000" cy="273600"/>
           </a:xfrm>
           <a:prstGeom prst="rect">
             <a:avLst/>
@@ -7794,7 +7934,7 @@
         <p:spPr>
           <a:xfrm>
             <a:off x="548640" y="5779080"/>
-            <a:ext cx="3483360" cy="502560"/>
+            <a:ext cx="3483000" cy="502200"/>
           </a:xfrm>
           <a:prstGeom prst="rect">
             <a:avLst/>
@@ -7851,7 +7991,7 @@
         <p:spPr>
           <a:xfrm>
             <a:off x="4352400" y="1965960"/>
-            <a:ext cx="3483360" cy="3428640"/>
+            <a:ext cx="3483000" cy="3428280"/>
           </a:xfrm>
           <a:prstGeom prst="roundRect">
             <a:avLst>
@@ -7886,6 +8026,11 @@
             <a:noAutofit/>
           </a:bodyPr>
           <a:p>
+            <a:pPr>
+              <a:lnSpc>
+                <a:spcPct val="100000"/>
+              </a:lnSpc>
+            </a:pPr>
             <a:endParaRPr b="0" lang="en-US" sz="1800" spc="-1" strike="noStrike">
               <a:solidFill>
                 <a:srgbClr val="000000"/>
@@ -7908,7 +8053,7 @@
         <p:spPr>
           <a:xfrm>
             <a:off x="4581000" y="2939400"/>
-            <a:ext cx="3026160" cy="1482120"/>
+            <a:ext cx="3025800" cy="1481760"/>
           </a:xfrm>
           <a:prstGeom prst="rect">
             <a:avLst/>
@@ -7927,7 +8072,7 @@
         <p:spPr>
           <a:xfrm>
             <a:off x="4352400" y="5504760"/>
-            <a:ext cx="3483360" cy="273960"/>
+            <a:ext cx="3483000" cy="273600"/>
           </a:xfrm>
           <a:prstGeom prst="rect">
             <a:avLst/>
@@ -7984,7 +8129,7 @@
         <p:spPr>
           <a:xfrm>
             <a:off x="4352400" y="5779080"/>
-            <a:ext cx="3483360" cy="502560"/>
+            <a:ext cx="3483000" cy="502200"/>
           </a:xfrm>
           <a:prstGeom prst="rect">
             <a:avLst/>
@@ -8041,7 +8186,7 @@
         <p:spPr>
           <a:xfrm>
             <a:off x="8156520" y="1965960"/>
-            <a:ext cx="3483360" cy="3428640"/>
+            <a:ext cx="3483000" cy="3428280"/>
           </a:xfrm>
           <a:prstGeom prst="roundRect">
             <a:avLst>
@@ -8076,6 +8221,11 @@
             <a:noAutofit/>
           </a:bodyPr>
           <a:p>
+            <a:pPr>
+              <a:lnSpc>
+                <a:spcPct val="100000"/>
+              </a:lnSpc>
+            </a:pPr>
             <a:endParaRPr b="0" lang="en-US" sz="1800" spc="-1" strike="noStrike">
               <a:solidFill>
                 <a:srgbClr val="000000"/>
@@ -8098,7 +8248,7 @@
         <p:spPr>
           <a:xfrm>
             <a:off x="8385120" y="3232800"/>
-            <a:ext cx="3026160" cy="895320"/>
+            <a:ext cx="3025800" cy="894960"/>
           </a:xfrm>
           <a:prstGeom prst="rect">
             <a:avLst/>
@@ -8117,7 +8267,7 @@
         <p:spPr>
           <a:xfrm>
             <a:off x="8156520" y="5504760"/>
-            <a:ext cx="3483360" cy="273960"/>
+            <a:ext cx="3483000" cy="273600"/>
           </a:xfrm>
           <a:prstGeom prst="rect">
             <a:avLst/>
@@ -8174,7 +8324,7 @@
         <p:spPr>
           <a:xfrm>
             <a:off x="8156520" y="5779080"/>
-            <a:ext cx="3483360" cy="502560"/>
+            <a:ext cx="3483000" cy="502200"/>
           </a:xfrm>
           <a:prstGeom prst="rect">
             <a:avLst/>
@@ -8231,7 +8381,7 @@
         <p:spPr>
           <a:xfrm>
             <a:off x="548640" y="6355080"/>
-            <a:ext cx="11063880" cy="319680"/>
+            <a:ext cx="11063520" cy="319320"/>
           </a:xfrm>
           <a:prstGeom prst="rect">
             <a:avLst/>
@@ -8288,7 +8438,7 @@
         <p:spPr>
           <a:xfrm>
             <a:off x="11567160" y="6492240"/>
-            <a:ext cx="456840" cy="273960"/>
+            <a:ext cx="456480" cy="273600"/>
           </a:xfrm>
           <a:prstGeom prst="rect">
             <a:avLst/>
@@ -8382,7 +8532,7 @@
         <p:spPr>
           <a:xfrm>
             <a:off x="548640" y="384120"/>
-            <a:ext cx="7314840" cy="319680"/>
+            <a:ext cx="7314480" cy="319320"/>
           </a:xfrm>
           <a:prstGeom prst="rect">
             <a:avLst/>
@@ -8412,7 +8562,7 @@
               </a:tabLst>
             </a:pPr>
             <a:r>
-              <a:rPr b="1" lang="en-US" sz="1300" spc="199" strike="noStrike">
+              <a:rPr b="1" lang="en-US" sz="1300" spc="197" strike="noStrike">
                 <a:solidFill>
                   <a:srgbClr val="028090"/>
                 </a:solidFill>
@@ -8439,7 +8589,7 @@
         <p:spPr>
           <a:xfrm>
             <a:off x="548640" y="658440"/>
-            <a:ext cx="11063880" cy="822600"/>
+            <a:ext cx="11063520" cy="822240"/>
           </a:xfrm>
           <a:prstGeom prst="rect">
             <a:avLst/>
@@ -8496,7 +8646,7 @@
         <p:spPr>
           <a:xfrm>
             <a:off x="548640" y="1828800"/>
-            <a:ext cx="5120280" cy="1188360"/>
+            <a:ext cx="5119920" cy="1188000"/>
           </a:xfrm>
           <a:prstGeom prst="roundRect">
             <a:avLst>
@@ -8531,6 +8681,11 @@
             <a:noAutofit/>
           </a:bodyPr>
           <a:p>
+            <a:pPr>
+              <a:lnSpc>
+                <a:spcPct val="100000"/>
+              </a:lnSpc>
+            </a:pPr>
             <a:endParaRPr b="0" lang="en-US" sz="1800" spc="-1" strike="noStrike">
               <a:solidFill>
                 <a:srgbClr val="000000"/>
@@ -8549,7 +8704,7 @@
         <p:spPr>
           <a:xfrm>
             <a:off x="731520" y="1828800"/>
-            <a:ext cx="1737000" cy="1188360"/>
+            <a:ext cx="1736640" cy="1188000"/>
           </a:xfrm>
           <a:prstGeom prst="rect">
             <a:avLst/>
@@ -8606,7 +8761,7 @@
         <p:spPr>
           <a:xfrm>
             <a:off x="2560320" y="1828800"/>
-            <a:ext cx="2880000" cy="1188360"/>
+            <a:ext cx="2879640" cy="1188000"/>
           </a:xfrm>
           <a:prstGeom prst="rect">
             <a:avLst/>
@@ -8689,7 +8844,7 @@
         <p:spPr>
           <a:xfrm>
             <a:off x="548640" y="3246120"/>
-            <a:ext cx="5120280" cy="1188360"/>
+            <a:ext cx="5119920" cy="1188000"/>
           </a:xfrm>
           <a:prstGeom prst="roundRect">
             <a:avLst>
@@ -8724,6 +8879,11 @@
             <a:noAutofit/>
           </a:bodyPr>
           <a:p>
+            <a:pPr>
+              <a:lnSpc>
+                <a:spcPct val="100000"/>
+              </a:lnSpc>
+            </a:pPr>
             <a:endParaRPr b="0" lang="en-US" sz="1800" spc="-1" strike="noStrike">
               <a:solidFill>
                 <a:srgbClr val="000000"/>
@@ -8742,7 +8902,7 @@
         <p:spPr>
           <a:xfrm>
             <a:off x="731520" y="3246120"/>
-            <a:ext cx="1737000" cy="1188360"/>
+            <a:ext cx="1736640" cy="1188000"/>
           </a:xfrm>
           <a:prstGeom prst="rect">
             <a:avLst/>
@@ -8799,7 +8959,7 @@
         <p:spPr>
           <a:xfrm>
             <a:off x="2560320" y="3246120"/>
-            <a:ext cx="2880000" cy="1188360"/>
+            <a:ext cx="2879640" cy="1188000"/>
           </a:xfrm>
           <a:prstGeom prst="rect">
             <a:avLst/>
@@ -8882,7 +9042,7 @@
         <p:spPr>
           <a:xfrm>
             <a:off x="548640" y="4663440"/>
-            <a:ext cx="5120280" cy="1188360"/>
+            <a:ext cx="5119920" cy="1188000"/>
           </a:xfrm>
           <a:prstGeom prst="roundRect">
             <a:avLst>
@@ -8917,6 +9077,11 @@
             <a:noAutofit/>
           </a:bodyPr>
           <a:p>
+            <a:pPr>
+              <a:lnSpc>
+                <a:spcPct val="100000"/>
+              </a:lnSpc>
+            </a:pPr>
             <a:endParaRPr b="0" lang="en-US" sz="1800" spc="-1" strike="noStrike">
               <a:solidFill>
                 <a:srgbClr val="000000"/>
@@ -8935,7 +9100,7 @@
         <p:spPr>
           <a:xfrm>
             <a:off x="731520" y="4663440"/>
-            <a:ext cx="1737000" cy="1188360"/>
+            <a:ext cx="1736640" cy="1188000"/>
           </a:xfrm>
           <a:prstGeom prst="rect">
             <a:avLst/>
@@ -8992,7 +9157,7 @@
         <p:spPr>
           <a:xfrm>
             <a:off x="2560320" y="4663440"/>
-            <a:ext cx="2880000" cy="1188360"/>
+            <a:ext cx="2879640" cy="1188000"/>
           </a:xfrm>
           <a:prstGeom prst="rect">
             <a:avLst/>
@@ -9075,7 +9240,7 @@
         <p:spPr>
           <a:xfrm>
             <a:off x="6126480" y="1783080"/>
-            <a:ext cx="5486040" cy="365400"/>
+            <a:ext cx="5485680" cy="365040"/>
           </a:xfrm>
           <a:prstGeom prst="rect">
             <a:avLst/>
@@ -9132,7 +9297,7 @@
         <p:spPr>
           <a:xfrm>
             <a:off x="6126480" y="2240280"/>
-            <a:ext cx="310680" cy="310680"/>
+            <a:ext cx="310320" cy="310320"/>
           </a:xfrm>
           <a:prstGeom prst="ellipse">
             <a:avLst/>
@@ -9155,6 +9320,11 @@
             <a:noAutofit/>
           </a:bodyPr>
           <a:p>
+            <a:pPr>
+              <a:lnSpc>
+                <a:spcPct val="100000"/>
+              </a:lnSpc>
+            </a:pPr>
             <a:endParaRPr b="0" lang="en-US" sz="1800" spc="-1" strike="noStrike">
               <a:solidFill>
                 <a:srgbClr val="ffffff"/>
@@ -9173,7 +9343,7 @@
         <p:spPr>
           <a:xfrm>
             <a:off x="6126480" y="2240280"/>
-            <a:ext cx="310680" cy="310680"/>
+            <a:ext cx="310320" cy="310320"/>
           </a:xfrm>
           <a:prstGeom prst="rect">
             <a:avLst/>
@@ -9230,7 +9400,7 @@
         <p:spPr>
           <a:xfrm>
             <a:off x="6583680" y="2185560"/>
-            <a:ext cx="5120280" cy="776880"/>
+            <a:ext cx="5119920" cy="776520"/>
           </a:xfrm>
           <a:prstGeom prst="rect">
             <a:avLst/>
@@ -9287,7 +9457,7 @@
         <p:spPr>
           <a:xfrm>
             <a:off x="6126480" y="3173040"/>
-            <a:ext cx="310680" cy="310680"/>
+            <a:ext cx="310320" cy="310320"/>
           </a:xfrm>
           <a:prstGeom prst="ellipse">
             <a:avLst/>
@@ -9310,6 +9480,11 @@
             <a:noAutofit/>
           </a:bodyPr>
           <a:p>
+            <a:pPr>
+              <a:lnSpc>
+                <a:spcPct val="100000"/>
+              </a:lnSpc>
+            </a:pPr>
             <a:endParaRPr b="0" lang="en-US" sz="1800" spc="-1" strike="noStrike">
               <a:solidFill>
                 <a:srgbClr val="ffffff"/>
@@ -9328,7 +9503,7 @@
         <p:spPr>
           <a:xfrm>
             <a:off x="6126480" y="3173040"/>
-            <a:ext cx="310680" cy="310680"/>
+            <a:ext cx="310320" cy="310320"/>
           </a:xfrm>
           <a:prstGeom prst="rect">
             <a:avLst/>
@@ -9385,7 +9560,7 @@
         <p:spPr>
           <a:xfrm>
             <a:off x="6583680" y="3117960"/>
-            <a:ext cx="5120280" cy="776880"/>
+            <a:ext cx="5119920" cy="776520"/>
           </a:xfrm>
           <a:prstGeom prst="rect">
             <a:avLst/>
@@ -9442,7 +9617,7 @@
         <p:spPr>
           <a:xfrm>
             <a:off x="6126480" y="4105800"/>
-            <a:ext cx="310680" cy="310680"/>
+            <a:ext cx="310320" cy="310320"/>
           </a:xfrm>
           <a:prstGeom prst="ellipse">
             <a:avLst/>
@@ -9465,6 +9640,11 @@
             <a:noAutofit/>
           </a:bodyPr>
           <a:p>
+            <a:pPr>
+              <a:lnSpc>
+                <a:spcPct val="100000"/>
+              </a:lnSpc>
+            </a:pPr>
             <a:endParaRPr b="0" lang="en-US" sz="1800" spc="-1" strike="noStrike">
               <a:solidFill>
                 <a:srgbClr val="ffffff"/>
@@ -9483,7 +9663,7 @@
         <p:spPr>
           <a:xfrm>
             <a:off x="6126480" y="4105800"/>
-            <a:ext cx="310680" cy="310680"/>
+            <a:ext cx="310320" cy="310320"/>
           </a:xfrm>
           <a:prstGeom prst="rect">
             <a:avLst/>
@@ -9540,7 +9720,7 @@
         <p:spPr>
           <a:xfrm>
             <a:off x="6583680" y="4050720"/>
-            <a:ext cx="5120280" cy="776880"/>
+            <a:ext cx="5119920" cy="776520"/>
           </a:xfrm>
           <a:prstGeom prst="rect">
             <a:avLst/>
@@ -9597,7 +9777,7 @@
         <p:spPr>
           <a:xfrm>
             <a:off x="6126480" y="5038200"/>
-            <a:ext cx="310680" cy="310680"/>
+            <a:ext cx="310320" cy="310320"/>
           </a:xfrm>
           <a:prstGeom prst="ellipse">
             <a:avLst/>
@@ -9620,6 +9800,11 @@
             <a:noAutofit/>
           </a:bodyPr>
           <a:p>
+            <a:pPr>
+              <a:lnSpc>
+                <a:spcPct val="100000"/>
+              </a:lnSpc>
+            </a:pPr>
             <a:endParaRPr b="0" lang="en-US" sz="1800" spc="-1" strike="noStrike">
               <a:solidFill>
                 <a:srgbClr val="ffffff"/>
@@ -9638,7 +9823,7 @@
         <p:spPr>
           <a:xfrm>
             <a:off x="6126480" y="5038200"/>
-            <a:ext cx="310680" cy="310680"/>
+            <a:ext cx="310320" cy="310320"/>
           </a:xfrm>
           <a:prstGeom prst="rect">
             <a:avLst/>
@@ -9695,7 +9880,7 @@
         <p:spPr>
           <a:xfrm>
             <a:off x="6583680" y="4983480"/>
-            <a:ext cx="5120280" cy="776880"/>
+            <a:ext cx="5119920" cy="776520"/>
           </a:xfrm>
           <a:prstGeom prst="rect">
             <a:avLst/>
@@ -9752,7 +9937,7 @@
         <p:spPr>
           <a:xfrm>
             <a:off x="548640" y="6263640"/>
-            <a:ext cx="11063880" cy="319680"/>
+            <a:ext cx="11063520" cy="319320"/>
           </a:xfrm>
           <a:prstGeom prst="rect">
             <a:avLst/>
@@ -9809,7 +9994,7 @@
         <p:spPr>
           <a:xfrm>
             <a:off x="11567160" y="6492240"/>
-            <a:ext cx="456840" cy="273960"/>
+            <a:ext cx="456480" cy="273600"/>
           </a:xfrm>
           <a:prstGeom prst="rect">
             <a:avLst/>
@@ -9903,7 +10088,7 @@
         <p:spPr>
           <a:xfrm>
             <a:off x="548640" y="384120"/>
-            <a:ext cx="7314840" cy="319680"/>
+            <a:ext cx="7314480" cy="319320"/>
           </a:xfrm>
           <a:prstGeom prst="rect">
             <a:avLst/>
@@ -9933,7 +10118,7 @@
               </a:tabLst>
             </a:pPr>
             <a:r>
-              <a:rPr b="1" lang="en-US" sz="1300" spc="199" strike="noStrike">
+              <a:rPr b="1" lang="en-US" sz="1300" spc="197" strike="noStrike">
                 <a:solidFill>
                   <a:srgbClr val="02c39a"/>
                 </a:solidFill>
@@ -9960,7 +10145,7 @@
         <p:spPr>
           <a:xfrm>
             <a:off x="548640" y="658440"/>
-            <a:ext cx="11063880" cy="822600"/>
+            <a:ext cx="11063520" cy="822240"/>
           </a:xfrm>
           <a:prstGeom prst="rect">
             <a:avLst/>
@@ -10017,7 +10202,7 @@
         <p:spPr>
           <a:xfrm>
             <a:off x="548640" y="1691640"/>
-            <a:ext cx="3501720" cy="1965600"/>
+            <a:ext cx="3501360" cy="1965240"/>
           </a:xfrm>
           <a:prstGeom prst="roundRect">
             <a:avLst>
@@ -10045,6 +10230,11 @@
             <a:noAutofit/>
           </a:bodyPr>
           <a:p>
+            <a:pPr>
+              <a:lnSpc>
+                <a:spcPct val="100000"/>
+              </a:lnSpc>
+            </a:pPr>
             <a:endParaRPr b="0" lang="en-US" sz="1800" spc="-1" strike="noStrike">
               <a:solidFill>
                 <a:srgbClr val="ffffff"/>
@@ -10063,7 +10253,7 @@
         <p:spPr>
           <a:xfrm>
             <a:off x="777240" y="1856160"/>
-            <a:ext cx="3044520" cy="868320"/>
+            <a:ext cx="3044160" cy="867960"/>
           </a:xfrm>
           <a:prstGeom prst="rect">
             <a:avLst/>
@@ -10120,7 +10310,7 @@
         <p:spPr>
           <a:xfrm>
             <a:off x="777240" y="2743200"/>
-            <a:ext cx="3044520" cy="319680"/>
+            <a:ext cx="3044160" cy="319320"/>
           </a:xfrm>
           <a:prstGeom prst="rect">
             <a:avLst/>
@@ -10177,7 +10367,7 @@
         <p:spPr>
           <a:xfrm>
             <a:off x="777240" y="3081600"/>
-            <a:ext cx="3044520" cy="502560"/>
+            <a:ext cx="3044160" cy="502200"/>
           </a:xfrm>
           <a:prstGeom prst="rect">
             <a:avLst/>
@@ -10234,7 +10424,7 @@
         <p:spPr>
           <a:xfrm>
             <a:off x="4325040" y="1691640"/>
-            <a:ext cx="3501720" cy="1965600"/>
+            <a:ext cx="3501360" cy="1965240"/>
           </a:xfrm>
           <a:prstGeom prst="roundRect">
             <a:avLst>
@@ -10262,6 +10452,11 @@
             <a:noAutofit/>
           </a:bodyPr>
           <a:p>
+            <a:pPr>
+              <a:lnSpc>
+                <a:spcPct val="100000"/>
+              </a:lnSpc>
+            </a:pPr>
             <a:endParaRPr b="0" lang="en-US" sz="1800" spc="-1" strike="noStrike">
               <a:solidFill>
                 <a:srgbClr val="ffffff"/>
@@ -10280,7 +10475,7 @@
         <p:spPr>
           <a:xfrm>
             <a:off x="4553640" y="1856160"/>
-            <a:ext cx="3044520" cy="868320"/>
+            <a:ext cx="3044160" cy="867960"/>
           </a:xfrm>
           <a:prstGeom prst="rect">
             <a:avLst/>
@@ -10337,7 +10532,7 @@
         <p:spPr>
           <a:xfrm>
             <a:off x="4553640" y="2743200"/>
-            <a:ext cx="3044520" cy="319680"/>
+            <a:ext cx="3044160" cy="319320"/>
           </a:xfrm>
           <a:prstGeom prst="rect">
             <a:avLst/>
@@ -10394,7 +10589,7 @@
         <p:spPr>
           <a:xfrm>
             <a:off x="4553640" y="3081600"/>
-            <a:ext cx="3044520" cy="502560"/>
+            <a:ext cx="3044160" cy="502200"/>
           </a:xfrm>
           <a:prstGeom prst="rect">
             <a:avLst/>
@@ -10451,7 +10646,7 @@
         <p:spPr>
           <a:xfrm>
             <a:off x="8101440" y="1691640"/>
-            <a:ext cx="3501720" cy="1965600"/>
+            <a:ext cx="3501360" cy="1965240"/>
           </a:xfrm>
           <a:prstGeom prst="roundRect">
             <a:avLst>
@@ -10479,6 +10674,11 @@
             <a:noAutofit/>
           </a:bodyPr>
           <a:p>
+            <a:pPr>
+              <a:lnSpc>
+                <a:spcPct val="100000"/>
+              </a:lnSpc>
+            </a:pPr>
             <a:endParaRPr b="0" lang="en-US" sz="1800" spc="-1" strike="noStrike">
               <a:solidFill>
                 <a:srgbClr val="ffffff"/>
@@ -10497,7 +10697,7 @@
         <p:spPr>
           <a:xfrm>
             <a:off x="8330040" y="1856160"/>
-            <a:ext cx="3044520" cy="868320"/>
+            <a:ext cx="3044160" cy="867960"/>
           </a:xfrm>
           <a:prstGeom prst="rect">
             <a:avLst/>
@@ -10554,7 +10754,7 @@
         <p:spPr>
           <a:xfrm>
             <a:off x="8330040" y="2743200"/>
-            <a:ext cx="3044520" cy="319680"/>
+            <a:ext cx="3044160" cy="319320"/>
           </a:xfrm>
           <a:prstGeom prst="rect">
             <a:avLst/>
@@ -10611,7 +10811,7 @@
         <p:spPr>
           <a:xfrm>
             <a:off x="8330040" y="3081600"/>
-            <a:ext cx="3044520" cy="502560"/>
+            <a:ext cx="3044160" cy="502200"/>
           </a:xfrm>
           <a:prstGeom prst="rect">
             <a:avLst/>
@@ -10668,7 +10868,7 @@
         <p:spPr>
           <a:xfrm>
             <a:off x="548640" y="3977640"/>
-            <a:ext cx="7314840" cy="319680"/>
+            <a:ext cx="7314480" cy="319320"/>
           </a:xfrm>
           <a:prstGeom prst="rect">
             <a:avLst/>
@@ -10725,7 +10925,7 @@
         <p:spPr>
           <a:xfrm>
             <a:off x="548640" y="4480560"/>
-            <a:ext cx="731160" cy="411120"/>
+            <a:ext cx="730800" cy="410760"/>
           </a:xfrm>
           <a:prstGeom prst="rect">
             <a:avLst/>
@@ -10782,7 +10982,7 @@
         <p:spPr>
           <a:xfrm>
             <a:off x="1325880" y="4535280"/>
-            <a:ext cx="7863480" cy="301320"/>
+            <a:ext cx="7863120" cy="300960"/>
           </a:xfrm>
           <a:prstGeom prst="roundRect">
             <a:avLst>
@@ -10807,6 +11007,11 @@
             <a:noAutofit/>
           </a:bodyPr>
           <a:p>
+            <a:pPr>
+              <a:lnSpc>
+                <a:spcPct val="100000"/>
+              </a:lnSpc>
+            </a:pPr>
             <a:endParaRPr b="0" lang="en-US" sz="1800" spc="-1" strike="noStrike">
               <a:solidFill>
                 <a:srgbClr val="ffffff"/>
@@ -10825,7 +11030,7 @@
         <p:spPr>
           <a:xfrm>
             <a:off x="1325880" y="4535280"/>
-            <a:ext cx="6492960" cy="301320"/>
+            <a:ext cx="6492600" cy="300960"/>
           </a:xfrm>
           <a:prstGeom prst="roundRect">
             <a:avLst>
@@ -10850,6 +11055,11 @@
             <a:noAutofit/>
           </a:bodyPr>
           <a:p>
+            <a:pPr>
+              <a:lnSpc>
+                <a:spcPct val="100000"/>
+              </a:lnSpc>
+            </a:pPr>
             <a:endParaRPr b="0" lang="en-US" sz="1800" spc="-1" strike="noStrike">
               <a:solidFill>
                 <a:srgbClr val="ffffff"/>
@@ -10868,7 +11078,7 @@
         <p:spPr>
           <a:xfrm>
             <a:off x="7362000" y="4480560"/>
-            <a:ext cx="548280" cy="411120"/>
+            <a:ext cx="547920" cy="410760"/>
           </a:xfrm>
           <a:prstGeom prst="rect">
             <a:avLst/>
@@ -10925,7 +11135,7 @@
         <p:spPr>
           <a:xfrm>
             <a:off x="548640" y="5047560"/>
-            <a:ext cx="731160" cy="411120"/>
+            <a:ext cx="730800" cy="410760"/>
           </a:xfrm>
           <a:prstGeom prst="rect">
             <a:avLst/>
@@ -10982,7 +11192,7 @@
         <p:spPr>
           <a:xfrm>
             <a:off x="1325880" y="5102280"/>
-            <a:ext cx="7863480" cy="301320"/>
+            <a:ext cx="7863120" cy="300960"/>
           </a:xfrm>
           <a:prstGeom prst="roundRect">
             <a:avLst>
@@ -11007,6 +11217,11 @@
             <a:noAutofit/>
           </a:bodyPr>
           <a:p>
+            <a:pPr>
+              <a:lnSpc>
+                <a:spcPct val="100000"/>
+              </a:lnSpc>
+            </a:pPr>
             <a:endParaRPr b="0" lang="en-US" sz="1800" spc="-1" strike="noStrike">
               <a:solidFill>
                 <a:srgbClr val="ffffff"/>
@@ -11025,7 +11240,7 @@
         <p:spPr>
           <a:xfrm>
             <a:off x="1325880" y="5102280"/>
-            <a:ext cx="5537880" cy="301320"/>
+            <a:ext cx="5537520" cy="300960"/>
           </a:xfrm>
           <a:prstGeom prst="roundRect">
             <a:avLst>
@@ -11050,6 +11265,11 @@
             <a:noAutofit/>
           </a:bodyPr>
           <a:p>
+            <a:pPr>
+              <a:lnSpc>
+                <a:spcPct val="100000"/>
+              </a:lnSpc>
+            </a:pPr>
             <a:endParaRPr b="0" lang="en-US" sz="1800" spc="-1" strike="noStrike">
               <a:solidFill>
                 <a:srgbClr val="000000"/>
@@ -11068,7 +11288,7 @@
         <p:spPr>
           <a:xfrm>
             <a:off x="6406920" y="5047560"/>
-            <a:ext cx="548280" cy="411120"/>
+            <a:ext cx="547920" cy="410760"/>
           </a:xfrm>
           <a:prstGeom prst="rect">
             <a:avLst/>
@@ -11125,7 +11345,7 @@
         <p:spPr>
           <a:xfrm>
             <a:off x="548640" y="5989320"/>
-            <a:ext cx="11063880" cy="548280"/>
+            <a:ext cx="11063520" cy="547920"/>
           </a:xfrm>
           <a:prstGeom prst="rect">
             <a:avLst/>
@@ -11182,7 +11402,7 @@
         <p:spPr>
           <a:xfrm>
             <a:off x="11567160" y="6492240"/>
-            <a:ext cx="456840" cy="273960"/>
+            <a:ext cx="456480" cy="273600"/>
           </a:xfrm>
           <a:prstGeom prst="rect">
             <a:avLst/>
@@ -11276,7 +11496,7 @@
         <p:spPr>
           <a:xfrm>
             <a:off x="548640" y="384120"/>
-            <a:ext cx="7314840" cy="319680"/>
+            <a:ext cx="7314480" cy="319320"/>
           </a:xfrm>
           <a:prstGeom prst="rect">
             <a:avLst/>
@@ -11306,7 +11526,7 @@
               </a:tabLst>
             </a:pPr>
             <a:r>
-              <a:rPr b="1" lang="en-US" sz="1300" spc="199" strike="noStrike">
+              <a:rPr b="1" lang="en-US" sz="1300" spc="197" strike="noStrike">
                 <a:solidFill>
                   <a:srgbClr val="028090"/>
                 </a:solidFill>
@@ -11333,7 +11553,7 @@
         <p:spPr>
           <a:xfrm>
             <a:off x="548640" y="658440"/>
-            <a:ext cx="11063880" cy="822600"/>
+            <a:ext cx="11063520" cy="822240"/>
           </a:xfrm>
           <a:prstGeom prst="rect">
             <a:avLst/>
@@ -11390,7 +11610,7 @@
         <p:spPr>
           <a:xfrm>
             <a:off x="548640" y="1691640"/>
-            <a:ext cx="5394600" cy="1508400"/>
+            <a:ext cx="5394240" cy="1508040"/>
           </a:xfrm>
           <a:prstGeom prst="roundRect">
             <a:avLst>
@@ -11425,6 +11645,11 @@
             <a:noAutofit/>
           </a:bodyPr>
           <a:p>
+            <a:pPr>
+              <a:lnSpc>
+                <a:spcPct val="100000"/>
+              </a:lnSpc>
+            </a:pPr>
             <a:endParaRPr b="0" lang="en-US" sz="1800" spc="-1" strike="noStrike">
               <a:solidFill>
                 <a:srgbClr val="000000"/>
@@ -11443,7 +11668,7 @@
         <p:spPr>
           <a:xfrm>
             <a:off x="777240" y="1892880"/>
-            <a:ext cx="456840" cy="456840"/>
+            <a:ext cx="456480" cy="456480"/>
           </a:xfrm>
           <a:prstGeom prst="roundRect">
             <a:avLst>
@@ -11468,6 +11693,11 @@
             <a:noAutofit/>
           </a:bodyPr>
           <a:p>
+            <a:pPr>
+              <a:lnSpc>
+                <a:spcPct val="100000"/>
+              </a:lnSpc>
+            </a:pPr>
             <a:endParaRPr b="0" lang="en-US" sz="1800" spc="-1" strike="noStrike">
               <a:solidFill>
                 <a:srgbClr val="ffffff"/>
@@ -11486,7 +11716,7 @@
         <p:spPr>
           <a:xfrm>
             <a:off x="777240" y="1892880"/>
-            <a:ext cx="456840" cy="456840"/>
+            <a:ext cx="456480" cy="456480"/>
           </a:xfrm>
           <a:prstGeom prst="rect">
             <a:avLst/>
@@ -11543,7 +11773,7 @@
         <p:spPr>
           <a:xfrm>
             <a:off x="1417320" y="1856160"/>
-            <a:ext cx="4343040" cy="365400"/>
+            <a:ext cx="4342680" cy="365040"/>
           </a:xfrm>
           <a:prstGeom prst="rect">
             <a:avLst/>
@@ -11600,7 +11830,7 @@
         <p:spPr>
           <a:xfrm>
             <a:off x="1417320" y="2240280"/>
-            <a:ext cx="4343040" cy="868320"/>
+            <a:ext cx="4342680" cy="867960"/>
           </a:xfrm>
           <a:prstGeom prst="rect">
             <a:avLst/>
@@ -11657,7 +11887,7 @@
         <p:spPr>
           <a:xfrm>
             <a:off x="548640" y="3383280"/>
-            <a:ext cx="5394600" cy="1508400"/>
+            <a:ext cx="5394240" cy="1508040"/>
           </a:xfrm>
           <a:prstGeom prst="roundRect">
             <a:avLst>
@@ -11692,6 +11922,11 @@
             <a:noAutofit/>
           </a:bodyPr>
           <a:p>
+            <a:pPr>
+              <a:lnSpc>
+                <a:spcPct val="100000"/>
+              </a:lnSpc>
+            </a:pPr>
             <a:endParaRPr b="0" lang="en-US" sz="1800" spc="-1" strike="noStrike">
               <a:solidFill>
                 <a:srgbClr val="000000"/>
@@ -11710,7 +11945,7 @@
         <p:spPr>
           <a:xfrm>
             <a:off x="777240" y="3584520"/>
-            <a:ext cx="456840" cy="456840"/>
+            <a:ext cx="456480" cy="456480"/>
           </a:xfrm>
           <a:prstGeom prst="roundRect">
             <a:avLst>
@@ -11735,6 +11970,11 @@
             <a:noAutofit/>
           </a:bodyPr>
           <a:p>
+            <a:pPr>
+              <a:lnSpc>
+                <a:spcPct val="100000"/>
+              </a:lnSpc>
+            </a:pPr>
             <a:endParaRPr b="0" lang="en-US" sz="1800" spc="-1" strike="noStrike">
               <a:solidFill>
                 <a:srgbClr val="ffffff"/>
@@ -11753,7 +11993,7 @@
         <p:spPr>
           <a:xfrm>
             <a:off x="777240" y="3584520"/>
-            <a:ext cx="456840" cy="456840"/>
+            <a:ext cx="456480" cy="456480"/>
           </a:xfrm>
           <a:prstGeom prst="rect">
             <a:avLst/>
@@ -11810,7 +12050,7 @@
         <p:spPr>
           <a:xfrm>
             <a:off x="1417320" y="3547800"/>
-            <a:ext cx="4343040" cy="365400"/>
+            <a:ext cx="4342680" cy="365040"/>
           </a:xfrm>
           <a:prstGeom prst="rect">
             <a:avLst/>
@@ -11867,7 +12107,7 @@
         <p:spPr>
           <a:xfrm>
             <a:off x="1417320" y="3931920"/>
-            <a:ext cx="4343040" cy="868320"/>
+            <a:ext cx="4342680" cy="867960"/>
           </a:xfrm>
           <a:prstGeom prst="rect">
             <a:avLst/>
@@ -11924,7 +12164,7 @@
         <p:spPr>
           <a:xfrm>
             <a:off x="6263640" y="1691640"/>
-            <a:ext cx="5348880" cy="4708800"/>
+            <a:ext cx="5348520" cy="4708440"/>
           </a:xfrm>
           <a:prstGeom prst="roundRect">
             <a:avLst>
@@ -11949,6 +12189,11 @@
             <a:noAutofit/>
           </a:bodyPr>
           <a:p>
+            <a:pPr>
+              <a:lnSpc>
+                <a:spcPct val="100000"/>
+              </a:lnSpc>
+            </a:pPr>
             <a:endParaRPr b="0" lang="en-US" sz="1800" spc="-1" strike="noStrike">
               <a:solidFill>
                 <a:srgbClr val="ffffff"/>
@@ -11967,7 +12212,7 @@
         <p:spPr>
           <a:xfrm>
             <a:off x="6583680" y="1965960"/>
-            <a:ext cx="4754520" cy="365400"/>
+            <a:ext cx="4754160" cy="365040"/>
           </a:xfrm>
           <a:prstGeom prst="rect">
             <a:avLst/>
@@ -12024,7 +12269,7 @@
         <p:spPr>
           <a:xfrm>
             <a:off x="6583680" y="2560320"/>
-            <a:ext cx="118440" cy="118440"/>
+            <a:ext cx="118080" cy="118080"/>
           </a:xfrm>
           <a:prstGeom prst="ellipse">
             <a:avLst/>
@@ -12047,6 +12292,11 @@
             <a:noAutofit/>
           </a:bodyPr>
           <a:p>
+            <a:pPr>
+              <a:lnSpc>
+                <a:spcPct val="100000"/>
+              </a:lnSpc>
+            </a:pPr>
             <a:endParaRPr b="0" lang="en-US" sz="1800" spc="-1" strike="noStrike">
               <a:solidFill>
                 <a:srgbClr val="ffffff"/>
@@ -12065,7 +12315,7 @@
         <p:spPr>
           <a:xfrm>
             <a:off x="6858000" y="2404800"/>
-            <a:ext cx="4480200" cy="776880"/>
+            <a:ext cx="4479840" cy="776520"/>
           </a:xfrm>
           <a:prstGeom prst="rect">
             <a:avLst/>
@@ -12122,7 +12372,7 @@
         <p:spPr>
           <a:xfrm>
             <a:off x="6583680" y="3493080"/>
-            <a:ext cx="118440" cy="118440"/>
+            <a:ext cx="118080" cy="118080"/>
           </a:xfrm>
           <a:prstGeom prst="ellipse">
             <a:avLst/>
@@ -12145,6 +12395,11 @@
             <a:noAutofit/>
           </a:bodyPr>
           <a:p>
+            <a:pPr>
+              <a:lnSpc>
+                <a:spcPct val="100000"/>
+              </a:lnSpc>
+            </a:pPr>
             <a:endParaRPr b="0" lang="en-US" sz="1800" spc="-1" strike="noStrike">
               <a:solidFill>
                 <a:srgbClr val="ffffff"/>
@@ -12163,7 +12418,7 @@
         <p:spPr>
           <a:xfrm>
             <a:off x="6858000" y="3337560"/>
-            <a:ext cx="4480200" cy="776880"/>
+            <a:ext cx="4479840" cy="776520"/>
           </a:xfrm>
           <a:prstGeom prst="rect">
             <a:avLst/>
@@ -12220,7 +12475,7 @@
         <p:spPr>
           <a:xfrm>
             <a:off x="6583680" y="4425840"/>
-            <a:ext cx="118440" cy="118440"/>
+            <a:ext cx="118080" cy="118080"/>
           </a:xfrm>
           <a:prstGeom prst="ellipse">
             <a:avLst/>
@@ -12243,6 +12498,11 @@
             <a:noAutofit/>
           </a:bodyPr>
           <a:p>
+            <a:pPr>
+              <a:lnSpc>
+                <a:spcPct val="100000"/>
+              </a:lnSpc>
+            </a:pPr>
             <a:endParaRPr b="0" lang="en-US" sz="1800" spc="-1" strike="noStrike">
               <a:solidFill>
                 <a:srgbClr val="ffffff"/>
@@ -12261,7 +12521,7 @@
         <p:spPr>
           <a:xfrm>
             <a:off x="6858000" y="4270320"/>
-            <a:ext cx="4480200" cy="776880"/>
+            <a:ext cx="4479840" cy="776520"/>
           </a:xfrm>
           <a:prstGeom prst="rect">
             <a:avLst/>
@@ -12318,7 +12578,7 @@
         <p:spPr>
           <a:xfrm>
             <a:off x="6583680" y="5358240"/>
-            <a:ext cx="118440" cy="118440"/>
+            <a:ext cx="118080" cy="118080"/>
           </a:xfrm>
           <a:prstGeom prst="ellipse">
             <a:avLst/>
@@ -12341,6 +12601,11 @@
             <a:noAutofit/>
           </a:bodyPr>
           <a:p>
+            <a:pPr>
+              <a:lnSpc>
+                <a:spcPct val="100000"/>
+              </a:lnSpc>
+            </a:pPr>
             <a:endParaRPr b="0" lang="en-US" sz="1800" spc="-1" strike="noStrike">
               <a:solidFill>
                 <a:srgbClr val="ffffff"/>
@@ -12359,7 +12624,7 @@
         <p:spPr>
           <a:xfrm>
             <a:off x="6858000" y="5203080"/>
-            <a:ext cx="4480200" cy="776880"/>
+            <a:ext cx="4479840" cy="776520"/>
           </a:xfrm>
           <a:prstGeom prst="rect">
             <a:avLst/>
@@ -12416,7 +12681,7 @@
         <p:spPr>
           <a:xfrm>
             <a:off x="11567160" y="6492240"/>
-            <a:ext cx="456840" cy="273960"/>
+            <a:ext cx="456480" cy="273600"/>
           </a:xfrm>
           <a:prstGeom prst="rect">
             <a:avLst/>
@@ -12510,7 +12775,7 @@
         <p:spPr>
           <a:xfrm>
             <a:off x="-1371600" y="-1645920"/>
-            <a:ext cx="4388760" cy="4388760"/>
+            <a:ext cx="4388400" cy="4388400"/>
           </a:xfrm>
           <a:prstGeom prst="ellipse">
             <a:avLst/>
@@ -12535,6 +12800,11 @@
             <a:noAutofit/>
           </a:bodyPr>
           <a:p>
+            <a:pPr>
+              <a:lnSpc>
+                <a:spcPct val="100000"/>
+              </a:lnSpc>
+            </a:pPr>
             <a:endParaRPr b="0" lang="en-US" sz="1800" spc="-1" strike="noStrike">
               <a:solidFill>
                 <a:srgbClr val="ffffff"/>
@@ -12553,7 +12823,7 @@
         <p:spPr>
           <a:xfrm>
             <a:off x="9875520" y="3931920"/>
-            <a:ext cx="3840120" cy="3840120"/>
+            <a:ext cx="3839760" cy="3839760"/>
           </a:xfrm>
           <a:prstGeom prst="ellipse">
             <a:avLst/>
@@ -12578,6 +12848,11 @@
             <a:noAutofit/>
           </a:bodyPr>
           <a:p>
+            <a:pPr>
+              <a:lnSpc>
+                <a:spcPct val="100000"/>
+              </a:lnSpc>
+            </a:pPr>
             <a:endParaRPr b="0" lang="en-US" sz="1800" spc="-1" strike="noStrike">
               <a:solidFill>
                 <a:srgbClr val="ffffff"/>
@@ -12596,7 +12871,7 @@
         <p:spPr>
           <a:xfrm>
             <a:off x="731520" y="1234440"/>
-            <a:ext cx="10515240" cy="868320"/>
+            <a:ext cx="10514880" cy="867960"/>
           </a:xfrm>
           <a:prstGeom prst="rect">
             <a:avLst/>
@@ -12653,7 +12928,7 @@
         <p:spPr>
           <a:xfrm>
             <a:off x="731520" y="2084760"/>
-            <a:ext cx="10515240" cy="502560"/>
+            <a:ext cx="10514880" cy="502200"/>
           </a:xfrm>
           <a:prstGeom prst="rect">
             <a:avLst/>
@@ -12751,7 +13026,7 @@
         <p:spPr>
           <a:xfrm>
             <a:off x="731520" y="3145680"/>
-            <a:ext cx="100080" cy="100080"/>
+            <a:ext cx="99720" cy="99720"/>
           </a:xfrm>
           <a:prstGeom prst="ellipse">
             <a:avLst/>
@@ -12774,6 +13049,11 @@
             <a:noAutofit/>
           </a:bodyPr>
           <a:p>
+            <a:pPr>
+              <a:lnSpc>
+                <a:spcPct val="100000"/>
+              </a:lnSpc>
+            </a:pPr>
             <a:endParaRPr b="0" lang="en-US" sz="1800" spc="-1" strike="noStrike">
               <a:solidFill>
                 <a:srgbClr val="ffffff"/>
@@ -12792,7 +13072,7 @@
         <p:spPr>
           <a:xfrm>
             <a:off x="1005840" y="2971800"/>
-            <a:ext cx="9600840" cy="383760"/>
+            <a:ext cx="9600480" cy="383400"/>
           </a:xfrm>
           <a:prstGeom prst="rect">
             <a:avLst/>
@@ -12859,7 +13139,7 @@
         <p:spPr>
           <a:xfrm>
             <a:off x="731520" y="3620880"/>
-            <a:ext cx="100080" cy="100080"/>
+            <a:ext cx="99720" cy="99720"/>
           </a:xfrm>
           <a:prstGeom prst="ellipse">
             <a:avLst/>
@@ -12882,6 +13162,11 @@
             <a:noAutofit/>
           </a:bodyPr>
           <a:p>
+            <a:pPr>
+              <a:lnSpc>
+                <a:spcPct val="100000"/>
+              </a:lnSpc>
+            </a:pPr>
             <a:endParaRPr b="0" lang="en-US" sz="1800" spc="-1" strike="noStrike">
               <a:solidFill>
                 <a:srgbClr val="ffffff"/>
@@ -12900,7 +13185,7 @@
         <p:spPr>
           <a:xfrm>
             <a:off x="1005840" y="3447360"/>
-            <a:ext cx="9600840" cy="383760"/>
+            <a:ext cx="9600480" cy="383400"/>
           </a:xfrm>
           <a:prstGeom prst="rect">
             <a:avLst/>
@@ -12967,7 +13252,7 @@
         <p:spPr>
           <a:xfrm>
             <a:off x="731520" y="4096440"/>
-            <a:ext cx="100080" cy="100080"/>
+            <a:ext cx="99720" cy="99720"/>
           </a:xfrm>
           <a:prstGeom prst="ellipse">
             <a:avLst/>
@@ -12990,6 +13275,11 @@
             <a:noAutofit/>
           </a:bodyPr>
           <a:p>
+            <a:pPr>
+              <a:lnSpc>
+                <a:spcPct val="100000"/>
+              </a:lnSpc>
+            </a:pPr>
             <a:endParaRPr b="0" lang="en-US" sz="1800" spc="-1" strike="noStrike">
               <a:solidFill>
                 <a:srgbClr val="ffffff"/>
@@ -13008,7 +13298,7 @@
         <p:spPr>
           <a:xfrm>
             <a:off x="1005840" y="3922920"/>
-            <a:ext cx="9600840" cy="383760"/>
+            <a:ext cx="9600480" cy="383400"/>
           </a:xfrm>
           <a:prstGeom prst="rect">
             <a:avLst/>
@@ -13075,7 +13365,7 @@
         <p:spPr>
           <a:xfrm>
             <a:off x="731520" y="4572000"/>
-            <a:ext cx="100080" cy="100080"/>
+            <a:ext cx="99720" cy="99720"/>
           </a:xfrm>
           <a:prstGeom prst="ellipse">
             <a:avLst/>
@@ -13098,6 +13388,11 @@
             <a:noAutofit/>
           </a:bodyPr>
           <a:p>
+            <a:pPr>
+              <a:lnSpc>
+                <a:spcPct val="100000"/>
+              </a:lnSpc>
+            </a:pPr>
             <a:endParaRPr b="0" lang="en-US" sz="1800" spc="-1" strike="noStrike">
               <a:solidFill>
                 <a:srgbClr val="ffffff"/>
@@ -13116,7 +13411,7 @@
         <p:spPr>
           <a:xfrm>
             <a:off x="1005840" y="4398120"/>
-            <a:ext cx="9600840" cy="383760"/>
+            <a:ext cx="9600480" cy="383400"/>
           </a:xfrm>
           <a:prstGeom prst="rect">
             <a:avLst/>
@@ -13183,7 +13478,7 @@
         <p:spPr>
           <a:xfrm>
             <a:off x="731520" y="5047560"/>
-            <a:ext cx="100080" cy="100080"/>
+            <a:ext cx="99720" cy="99720"/>
           </a:xfrm>
           <a:prstGeom prst="ellipse">
             <a:avLst/>
@@ -13206,6 +13501,11 @@
             <a:noAutofit/>
           </a:bodyPr>
           <a:p>
+            <a:pPr>
+              <a:lnSpc>
+                <a:spcPct val="100000"/>
+              </a:lnSpc>
+            </a:pPr>
             <a:endParaRPr b="0" lang="en-US" sz="1800" spc="-1" strike="noStrike">
               <a:solidFill>
                 <a:srgbClr val="ffffff"/>
@@ -13224,7 +13524,7 @@
         <p:spPr>
           <a:xfrm>
             <a:off x="1005840" y="4873680"/>
-            <a:ext cx="9600840" cy="383760"/>
+            <a:ext cx="9600480" cy="383400"/>
           </a:xfrm>
           <a:prstGeom prst="rect">
             <a:avLst/>
@@ -13274,6 +13574,166 @@
               <a:t>irene-angelica.chounta@uni-due.de</a:t>
             </a:r>
             <a:endParaRPr b="0" lang="en-US" sz="1350" spc="-1" strike="noStrike">
+              <a:solidFill>
+                <a:srgbClr val="ffffff"/>
+              </a:solidFill>
+              <a:latin typeface="Arial"/>
+            </a:endParaRPr>
+          </a:p>
+        </p:txBody>
+      </p:sp>
+      <p:pic>
+        <p:nvPicPr>
+          <p:cNvPr id="176" name="" descr=""/>
+          <p:cNvPicPr/>
+          <p:nvPr/>
+        </p:nvPicPr>
+        <p:blipFill>
+          <a:blip r:embed="rId1"/>
+          <a:stretch/>
+        </p:blipFill>
+        <p:spPr>
+          <a:xfrm>
+            <a:off x="7369920" y="660960"/>
+            <a:ext cx="1947600" cy="1961640"/>
+          </a:xfrm>
+          <a:prstGeom prst="rect">
+            <a:avLst/>
+          </a:prstGeom>
+          <a:ln w="0">
+            <a:noFill/>
+          </a:ln>
+        </p:spPr>
+      </p:pic>
+      <p:sp>
+        <p:nvSpPr>
+          <p:cNvPr id="177" name="Text 57"/>
+          <p:cNvSpPr/>
+          <p:nvPr/>
+        </p:nvSpPr>
+        <p:spPr>
+          <a:xfrm>
+            <a:off x="7278840" y="2608560"/>
+            <a:ext cx="2129760" cy="383400"/>
+          </a:xfrm>
+          <a:prstGeom prst="rect">
+            <a:avLst/>
+          </a:prstGeom>
+          <a:noFill/>
+          <a:ln w="0">
+            <a:noFill/>
+          </a:ln>
+        </p:spPr>
+        <p:style>
+          <a:lnRef idx="0"/>
+          <a:fillRef idx="0"/>
+          <a:effectRef idx="0"/>
+          <a:fontRef idx="minor"/>
+        </p:style>
+        <p:txBody>
+          <a:bodyPr lIns="90000" rIns="90000" tIns="45000" bIns="45000" anchor="ctr">
+            <a:noAutofit/>
+          </a:bodyPr>
+          <a:p>
+            <a:pPr algn="ctr" defTabSz="914400">
+              <a:lnSpc>
+                <a:spcPct val="100000"/>
+              </a:lnSpc>
+              <a:tabLst>
+                <a:tab algn="l" pos="0"/>
+              </a:tabLst>
+            </a:pPr>
+            <a:r>
+              <a:rPr b="0" lang="en-US" sz="1600" spc="-1" strike="noStrike">
+                <a:solidFill>
+                  <a:srgbClr val="ffffff"/>
+                </a:solidFill>
+                <a:latin typeface="Calibri"/>
+                <a:ea typeface="Calibri"/>
+              </a:rPr>
+              <a:t>Video of the Extension</a:t>
+            </a:r>
+            <a:endParaRPr b="0" lang="en-US" sz="1600" spc="-1" strike="noStrike">
+              <a:solidFill>
+                <a:srgbClr val="ffffff"/>
+              </a:solidFill>
+              <a:latin typeface="Arial"/>
+            </a:endParaRPr>
+          </a:p>
+        </p:txBody>
+      </p:sp>
+      <p:pic>
+        <p:nvPicPr>
+          <p:cNvPr id="178" name="" descr=""/>
+          <p:cNvPicPr/>
+          <p:nvPr/>
+        </p:nvPicPr>
+        <p:blipFill>
+          <a:blip r:embed="rId2"/>
+          <a:stretch/>
+        </p:blipFill>
+        <p:spPr>
+          <a:xfrm>
+            <a:off x="7340400" y="3589200"/>
+            <a:ext cx="2007000" cy="2028600"/>
+          </a:xfrm>
+          <a:prstGeom prst="rect">
+            <a:avLst/>
+          </a:prstGeom>
+          <a:ln w="0">
+            <a:noFill/>
+          </a:ln>
+        </p:spPr>
+      </p:pic>
+      <p:sp>
+        <p:nvSpPr>
+          <p:cNvPr id="179" name="Text 58"/>
+          <p:cNvSpPr/>
+          <p:nvPr/>
+        </p:nvSpPr>
+        <p:spPr>
+          <a:xfrm>
+            <a:off x="7278840" y="5617080"/>
+            <a:ext cx="2129760" cy="383400"/>
+          </a:xfrm>
+          <a:prstGeom prst="rect">
+            <a:avLst/>
+          </a:prstGeom>
+          <a:noFill/>
+          <a:ln w="0">
+            <a:noFill/>
+          </a:ln>
+        </p:spPr>
+        <p:style>
+          <a:lnRef idx="0"/>
+          <a:fillRef idx="0"/>
+          <a:effectRef idx="0"/>
+          <a:fontRef idx="minor"/>
+        </p:style>
+        <p:txBody>
+          <a:bodyPr lIns="90000" rIns="90000" tIns="45000" bIns="45000" anchor="ctr">
+            <a:noAutofit/>
+          </a:bodyPr>
+          <a:p>
+            <a:pPr algn="ctr" defTabSz="914400">
+              <a:lnSpc>
+                <a:spcPct val="100000"/>
+              </a:lnSpc>
+              <a:tabLst>
+                <a:tab algn="l" pos="0"/>
+              </a:tabLst>
+            </a:pPr>
+            <a:r>
+              <a:rPr b="0" lang="en-US" sz="1600" spc="-1" strike="noStrike">
+                <a:solidFill>
+                  <a:srgbClr val="ffffff"/>
+                </a:solidFill>
+                <a:latin typeface="Calibri"/>
+                <a:ea typeface="Calibri"/>
+              </a:rPr>
+              <a:t>https://colaps.team/</a:t>
+            </a:r>
+            <a:endParaRPr b="0" lang="en-US" sz="1600" spc="-1" strike="noStrike">
               <a:solidFill>
                 <a:srgbClr val="ffffff"/>
               </a:solidFill>

</xml_diff>